<commit_message>
Enhance service classes and Flask routes with detailed docstrings
</commit_message>
<xml_diff>
--- a/presentations/FirstFaults_Presentation-NL.pptx
+++ b/presentations/FirstFaults_Presentation-NL.pptx
@@ -5,23 +5,23 @@
     <p:sldMasterId id="2147483648" r:id="rId1"/>
   </p:sldMasterIdLst>
   <p:sldIdLst>
-    <p:sldId id="256" r:id="rId7"/>
-    <p:sldId id="257" r:id="rId8"/>
-    <p:sldId id="258" r:id="rId9"/>
-    <p:sldId id="259" r:id="rId10"/>
-    <p:sldId id="260" r:id="rId11"/>
-    <p:sldId id="261" r:id="rId12"/>
-    <p:sldId id="262" r:id="rId13"/>
-    <p:sldId id="263" r:id="rId14"/>
-    <p:sldId id="264" r:id="rId15"/>
-    <p:sldId id="265" r:id="rId16"/>
-    <p:sldId id="266" r:id="rId17"/>
-    <p:sldId id="267" r:id="rId18"/>
-    <p:sldId id="268" r:id="rId19"/>
-    <p:sldId id="269" r:id="rId20"/>
-    <p:sldId id="270" r:id="rId21"/>
+    <p:sldId id="256" r:id="rId2"/>
+    <p:sldId id="257" r:id="rId3"/>
+    <p:sldId id="258" r:id="rId4"/>
+    <p:sldId id="259" r:id="rId5"/>
+    <p:sldId id="260" r:id="rId6"/>
+    <p:sldId id="261" r:id="rId7"/>
+    <p:sldId id="262" r:id="rId8"/>
+    <p:sldId id="263" r:id="rId9"/>
+    <p:sldId id="264" r:id="rId10"/>
+    <p:sldId id="265" r:id="rId11"/>
+    <p:sldId id="266" r:id="rId12"/>
+    <p:sldId id="267" r:id="rId13"/>
+    <p:sldId id="268" r:id="rId14"/>
+    <p:sldId id="269" r:id="rId15"/>
+    <p:sldId id="270" r:id="rId16"/>
   </p:sldIdLst>
-  <p:sldSz cx="12188952" cy="6858000" type="screen4x3"/>
+  <p:sldSz cx="12188825" cy="6858000"/>
   <p:notesSz cx="6858000" cy="9144000"/>
   <p:defaultTextStyle>
     <a:defPPr>
@@ -118,6 +118,22 @@
       </a:defRPr>
     </a:lvl9pPr>
   </p:defaultTextStyle>
+  <p:extLst>
+    <p:ext uri="{EFAFB233-063F-42B5-8137-9DF3F51BA10A}">
+      <p15:sldGuideLst xmlns:p15="http://schemas.microsoft.com/office/powerpoint/2012/main">
+        <p15:guide id="1" orient="horz" pos="2160">
+          <p15:clr>
+            <a:srgbClr val="A4A3A4"/>
+          </p15:clr>
+        </p15:guide>
+        <p15:guide id="2" pos="2880">
+          <p15:clr>
+            <a:srgbClr val="A4A3A4"/>
+          </p15:clr>
+        </p15:guide>
+      </p15:sldGuideLst>
+    </p:ext>
+  </p:extLst>
 </p:presentation>
 </file>
 
@@ -159,10 +175,9 @@
           <a:lstStyle/>
           <a:p>
             <a:r>
-              <a:rPr lang="en-US" smtClean="0"/>
+              <a:rPr lang="en-US"/>
               <a:t>Click to edit Master title style</a:t>
             </a:r>
-            <a:endParaRPr lang="en-US"/>
           </a:p>
         </p:txBody>
       </p:sp>
@@ -278,10 +293,9 @@
           </a:lstStyle>
           <a:p>
             <a:r>
-              <a:rPr lang="en-US" smtClean="0"/>
+              <a:rPr lang="en-US"/>
               <a:t>Click to edit Master subtitle style</a:t>
             </a:r>
-            <a:endParaRPr lang="en-US"/>
           </a:p>
         </p:txBody>
       </p:sp>
@@ -302,7 +316,7 @@
           <a:p>
             <a:fld id="{5BCAD085-E8A6-8845-BD4E-CB4CCA059FC4}" type="datetimeFigureOut">
               <a:rPr lang="en-US" smtClean="0"/>
-              <a:t>1/27/13</a:t>
+              <a:t>6/7/26</a:t>
             </a:fld>
             <a:endParaRPr lang="en-US"/>
           </a:p>
@@ -396,10 +410,9 @@
           <a:lstStyle/>
           <a:p>
             <a:r>
-              <a:rPr lang="en-US" smtClean="0"/>
+              <a:rPr lang="en-US"/>
               <a:t>Click to edit Master title style</a:t>
             </a:r>
-            <a:endParaRPr lang="en-US"/>
           </a:p>
         </p:txBody>
       </p:sp>
@@ -420,38 +433,37 @@
           <a:p>
             <a:pPr lvl="0"/>
             <a:r>
-              <a:rPr lang="en-US" smtClean="0"/>
+              <a:rPr lang="en-US"/>
               <a:t>Click to edit Master text styles</a:t>
             </a:r>
           </a:p>
           <a:p>
             <a:pPr lvl="1"/>
             <a:r>
-              <a:rPr lang="en-US" smtClean="0"/>
+              <a:rPr lang="en-US"/>
               <a:t>Second level</a:t>
             </a:r>
           </a:p>
           <a:p>
             <a:pPr lvl="2"/>
             <a:r>
-              <a:rPr lang="en-US" smtClean="0"/>
+              <a:rPr lang="en-US"/>
               <a:t>Third level</a:t>
             </a:r>
           </a:p>
           <a:p>
             <a:pPr lvl="3"/>
             <a:r>
-              <a:rPr lang="en-US" smtClean="0"/>
+              <a:rPr lang="en-US"/>
               <a:t>Fourth level</a:t>
             </a:r>
           </a:p>
           <a:p>
             <a:pPr lvl="4"/>
             <a:r>
-              <a:rPr lang="en-US" smtClean="0"/>
+              <a:rPr lang="en-US"/>
               <a:t>Fifth level</a:t>
             </a:r>
-            <a:endParaRPr lang="en-US"/>
           </a:p>
         </p:txBody>
       </p:sp>
@@ -472,7 +484,7 @@
           <a:p>
             <a:fld id="{5BCAD085-E8A6-8845-BD4E-CB4CCA059FC4}" type="datetimeFigureOut">
               <a:rPr lang="en-US" smtClean="0"/>
-              <a:t>1/27/13</a:t>
+              <a:t>6/7/26</a:t>
             </a:fld>
             <a:endParaRPr lang="en-US"/>
           </a:p>
@@ -571,10 +583,9 @@
           <a:lstStyle/>
           <a:p>
             <a:r>
-              <a:rPr lang="en-US" smtClean="0"/>
+              <a:rPr lang="en-US"/>
               <a:t>Click to edit Master title style</a:t>
             </a:r>
-            <a:endParaRPr lang="en-US"/>
           </a:p>
         </p:txBody>
       </p:sp>
@@ -600,38 +611,37 @@
           <a:p>
             <a:pPr lvl="0"/>
             <a:r>
-              <a:rPr lang="en-US" smtClean="0"/>
+              <a:rPr lang="en-US"/>
               <a:t>Click to edit Master text styles</a:t>
             </a:r>
           </a:p>
           <a:p>
             <a:pPr lvl="1"/>
             <a:r>
-              <a:rPr lang="en-US" smtClean="0"/>
+              <a:rPr lang="en-US"/>
               <a:t>Second level</a:t>
             </a:r>
           </a:p>
           <a:p>
             <a:pPr lvl="2"/>
             <a:r>
-              <a:rPr lang="en-US" smtClean="0"/>
+              <a:rPr lang="en-US"/>
               <a:t>Third level</a:t>
             </a:r>
           </a:p>
           <a:p>
             <a:pPr lvl="3"/>
             <a:r>
-              <a:rPr lang="en-US" smtClean="0"/>
+              <a:rPr lang="en-US"/>
               <a:t>Fourth level</a:t>
             </a:r>
           </a:p>
           <a:p>
             <a:pPr lvl="4"/>
             <a:r>
-              <a:rPr lang="en-US" smtClean="0"/>
+              <a:rPr lang="en-US"/>
               <a:t>Fifth level</a:t>
             </a:r>
-            <a:endParaRPr lang="en-US"/>
           </a:p>
         </p:txBody>
       </p:sp>
@@ -652,7 +662,7 @@
           <a:p>
             <a:fld id="{5BCAD085-E8A6-8845-BD4E-CB4CCA059FC4}" type="datetimeFigureOut">
               <a:rPr lang="en-US" smtClean="0"/>
-              <a:t>1/27/13</a:t>
+              <a:t>6/7/26</a:t>
             </a:fld>
             <a:endParaRPr lang="en-US"/>
           </a:p>
@@ -746,10 +756,9 @@
           <a:lstStyle/>
           <a:p>
             <a:r>
-              <a:rPr lang="en-US" smtClean="0"/>
+              <a:rPr lang="en-US"/>
               <a:t>Click to edit Master title style</a:t>
             </a:r>
-            <a:endParaRPr lang="en-US"/>
           </a:p>
         </p:txBody>
       </p:sp>
@@ -770,38 +779,37 @@
           <a:p>
             <a:pPr lvl="0"/>
             <a:r>
-              <a:rPr lang="en-US" smtClean="0"/>
+              <a:rPr lang="en-US"/>
               <a:t>Click to edit Master text styles</a:t>
             </a:r>
           </a:p>
           <a:p>
             <a:pPr lvl="1"/>
             <a:r>
-              <a:rPr lang="en-US" smtClean="0"/>
+              <a:rPr lang="en-US"/>
               <a:t>Second level</a:t>
             </a:r>
           </a:p>
           <a:p>
             <a:pPr lvl="2"/>
             <a:r>
-              <a:rPr lang="en-US" smtClean="0"/>
+              <a:rPr lang="en-US"/>
               <a:t>Third level</a:t>
             </a:r>
           </a:p>
           <a:p>
             <a:pPr lvl="3"/>
             <a:r>
-              <a:rPr lang="en-US" smtClean="0"/>
+              <a:rPr lang="en-US"/>
               <a:t>Fourth level</a:t>
             </a:r>
           </a:p>
           <a:p>
             <a:pPr lvl="4"/>
             <a:r>
-              <a:rPr lang="en-US" smtClean="0"/>
+              <a:rPr lang="en-US"/>
               <a:t>Fifth level</a:t>
             </a:r>
-            <a:endParaRPr lang="en-US"/>
           </a:p>
         </p:txBody>
       </p:sp>
@@ -822,7 +830,7 @@
           <a:p>
             <a:fld id="{5BCAD085-E8A6-8845-BD4E-CB4CCA059FC4}" type="datetimeFigureOut">
               <a:rPr lang="en-US" smtClean="0"/>
-              <a:t>1/27/13</a:t>
+              <a:t>6/7/26</a:t>
             </a:fld>
             <a:endParaRPr lang="en-US"/>
           </a:p>
@@ -925,10 +933,9 @@
           </a:lstStyle>
           <a:p>
             <a:r>
-              <a:rPr lang="en-US" smtClean="0"/>
+              <a:rPr lang="en-US"/>
               <a:t>Click to edit Master title style</a:t>
             </a:r>
-            <a:endParaRPr lang="en-US"/>
           </a:p>
         </p:txBody>
       </p:sp>
@@ -1045,7 +1052,7 @@
           <a:p>
             <a:pPr lvl="0"/>
             <a:r>
-              <a:rPr lang="en-US" smtClean="0"/>
+              <a:rPr lang="en-US"/>
               <a:t>Click to edit Master text styles</a:t>
             </a:r>
           </a:p>
@@ -1068,7 +1075,7 @@
           <a:p>
             <a:fld id="{5BCAD085-E8A6-8845-BD4E-CB4CCA059FC4}" type="datetimeFigureOut">
               <a:rPr lang="en-US" smtClean="0"/>
-              <a:t>1/27/13</a:t>
+              <a:t>6/7/26</a:t>
             </a:fld>
             <a:endParaRPr lang="en-US"/>
           </a:p>
@@ -1162,10 +1169,9 @@
           <a:lstStyle/>
           <a:p>
             <a:r>
-              <a:rPr lang="en-US" smtClean="0"/>
+              <a:rPr lang="en-US"/>
               <a:t>Click to edit Master title style</a:t>
             </a:r>
-            <a:endParaRPr lang="en-US"/>
           </a:p>
         </p:txBody>
       </p:sp>
@@ -1219,38 +1225,37 @@
           <a:p>
             <a:pPr lvl="0"/>
             <a:r>
-              <a:rPr lang="en-US" smtClean="0"/>
+              <a:rPr lang="en-US"/>
               <a:t>Click to edit Master text styles</a:t>
             </a:r>
           </a:p>
           <a:p>
             <a:pPr lvl="1"/>
             <a:r>
-              <a:rPr lang="en-US" smtClean="0"/>
+              <a:rPr lang="en-US"/>
               <a:t>Second level</a:t>
             </a:r>
           </a:p>
           <a:p>
             <a:pPr lvl="2"/>
             <a:r>
-              <a:rPr lang="en-US" smtClean="0"/>
+              <a:rPr lang="en-US"/>
               <a:t>Third level</a:t>
             </a:r>
           </a:p>
           <a:p>
             <a:pPr lvl="3"/>
             <a:r>
-              <a:rPr lang="en-US" smtClean="0"/>
+              <a:rPr lang="en-US"/>
               <a:t>Fourth level</a:t>
             </a:r>
           </a:p>
           <a:p>
             <a:pPr lvl="4"/>
             <a:r>
-              <a:rPr lang="en-US" smtClean="0"/>
+              <a:rPr lang="en-US"/>
               <a:t>Fifth level</a:t>
             </a:r>
-            <a:endParaRPr lang="en-US"/>
           </a:p>
         </p:txBody>
       </p:sp>
@@ -1304,38 +1309,37 @@
           <a:p>
             <a:pPr lvl="0"/>
             <a:r>
-              <a:rPr lang="en-US" smtClean="0"/>
+              <a:rPr lang="en-US"/>
               <a:t>Click to edit Master text styles</a:t>
             </a:r>
           </a:p>
           <a:p>
             <a:pPr lvl="1"/>
             <a:r>
-              <a:rPr lang="en-US" smtClean="0"/>
+              <a:rPr lang="en-US"/>
               <a:t>Second level</a:t>
             </a:r>
           </a:p>
           <a:p>
             <a:pPr lvl="2"/>
             <a:r>
-              <a:rPr lang="en-US" smtClean="0"/>
+              <a:rPr lang="en-US"/>
               <a:t>Third level</a:t>
             </a:r>
           </a:p>
           <a:p>
             <a:pPr lvl="3"/>
             <a:r>
-              <a:rPr lang="en-US" smtClean="0"/>
+              <a:rPr lang="en-US"/>
               <a:t>Fourth level</a:t>
             </a:r>
           </a:p>
           <a:p>
             <a:pPr lvl="4"/>
             <a:r>
-              <a:rPr lang="en-US" smtClean="0"/>
+              <a:rPr lang="en-US"/>
               <a:t>Fifth level</a:t>
             </a:r>
-            <a:endParaRPr lang="en-US"/>
           </a:p>
         </p:txBody>
       </p:sp>
@@ -1356,7 +1360,7 @@
           <a:p>
             <a:fld id="{5BCAD085-E8A6-8845-BD4E-CB4CCA059FC4}" type="datetimeFigureOut">
               <a:rPr lang="en-US" smtClean="0"/>
-              <a:t>1/27/13</a:t>
+              <a:t>6/7/26</a:t>
             </a:fld>
             <a:endParaRPr lang="en-US"/>
           </a:p>
@@ -1454,10 +1458,9 @@
           </a:lstStyle>
           <a:p>
             <a:r>
-              <a:rPr lang="en-US" smtClean="0"/>
+              <a:rPr lang="en-US"/>
               <a:t>Click to edit Master title style</a:t>
             </a:r>
-            <a:endParaRPr lang="en-US"/>
           </a:p>
         </p:txBody>
       </p:sp>
@@ -1520,7 +1523,7 @@
           <a:p>
             <a:pPr lvl="0"/>
             <a:r>
-              <a:rPr lang="en-US" smtClean="0"/>
+              <a:rPr lang="en-US"/>
               <a:t>Click to edit Master text styles</a:t>
             </a:r>
           </a:p>
@@ -1576,38 +1579,37 @@
           <a:p>
             <a:pPr lvl="0"/>
             <a:r>
-              <a:rPr lang="en-US" smtClean="0"/>
+              <a:rPr lang="en-US"/>
               <a:t>Click to edit Master text styles</a:t>
             </a:r>
           </a:p>
           <a:p>
             <a:pPr lvl="1"/>
             <a:r>
-              <a:rPr lang="en-US" smtClean="0"/>
+              <a:rPr lang="en-US"/>
               <a:t>Second level</a:t>
             </a:r>
           </a:p>
           <a:p>
             <a:pPr lvl="2"/>
             <a:r>
-              <a:rPr lang="en-US" smtClean="0"/>
+              <a:rPr lang="en-US"/>
               <a:t>Third level</a:t>
             </a:r>
           </a:p>
           <a:p>
             <a:pPr lvl="3"/>
             <a:r>
-              <a:rPr lang="en-US" smtClean="0"/>
+              <a:rPr lang="en-US"/>
               <a:t>Fourth level</a:t>
             </a:r>
           </a:p>
           <a:p>
             <a:pPr lvl="4"/>
             <a:r>
-              <a:rPr lang="en-US" smtClean="0"/>
+              <a:rPr lang="en-US"/>
               <a:t>Fifth level</a:t>
             </a:r>
-            <a:endParaRPr lang="en-US"/>
           </a:p>
         </p:txBody>
       </p:sp>
@@ -1670,7 +1672,7 @@
           <a:p>
             <a:pPr lvl="0"/>
             <a:r>
-              <a:rPr lang="en-US" smtClean="0"/>
+              <a:rPr lang="en-US"/>
               <a:t>Click to edit Master text styles</a:t>
             </a:r>
           </a:p>
@@ -1726,38 +1728,37 @@
           <a:p>
             <a:pPr lvl="0"/>
             <a:r>
-              <a:rPr lang="en-US" smtClean="0"/>
+              <a:rPr lang="en-US"/>
               <a:t>Click to edit Master text styles</a:t>
             </a:r>
           </a:p>
           <a:p>
             <a:pPr lvl="1"/>
             <a:r>
-              <a:rPr lang="en-US" smtClean="0"/>
+              <a:rPr lang="en-US"/>
               <a:t>Second level</a:t>
             </a:r>
           </a:p>
           <a:p>
             <a:pPr lvl="2"/>
             <a:r>
-              <a:rPr lang="en-US" smtClean="0"/>
+              <a:rPr lang="en-US"/>
               <a:t>Third level</a:t>
             </a:r>
           </a:p>
           <a:p>
             <a:pPr lvl="3"/>
             <a:r>
-              <a:rPr lang="en-US" smtClean="0"/>
+              <a:rPr lang="en-US"/>
               <a:t>Fourth level</a:t>
             </a:r>
           </a:p>
           <a:p>
             <a:pPr lvl="4"/>
             <a:r>
-              <a:rPr lang="en-US" smtClean="0"/>
+              <a:rPr lang="en-US"/>
               <a:t>Fifth level</a:t>
             </a:r>
-            <a:endParaRPr lang="en-US"/>
           </a:p>
         </p:txBody>
       </p:sp>
@@ -1778,7 +1779,7 @@
           <a:p>
             <a:fld id="{5BCAD085-E8A6-8845-BD4E-CB4CCA059FC4}" type="datetimeFigureOut">
               <a:rPr lang="en-US" smtClean="0"/>
-              <a:t>1/27/13</a:t>
+              <a:t>6/7/26</a:t>
             </a:fld>
             <a:endParaRPr lang="en-US"/>
           </a:p>
@@ -1872,10 +1873,9 @@
           <a:lstStyle/>
           <a:p>
             <a:r>
-              <a:rPr lang="en-US" smtClean="0"/>
+              <a:rPr lang="en-US"/>
               <a:t>Click to edit Master title style</a:t>
             </a:r>
-            <a:endParaRPr lang="en-US"/>
           </a:p>
         </p:txBody>
       </p:sp>
@@ -1896,7 +1896,7 @@
           <a:p>
             <a:fld id="{5BCAD085-E8A6-8845-BD4E-CB4CCA059FC4}" type="datetimeFigureOut">
               <a:rPr lang="en-US" smtClean="0"/>
-              <a:t>1/27/13</a:t>
+              <a:t>6/7/26</a:t>
             </a:fld>
             <a:endParaRPr lang="en-US"/>
           </a:p>
@@ -1991,7 +1991,7 @@
           <a:p>
             <a:fld id="{5BCAD085-E8A6-8845-BD4E-CB4CCA059FC4}" type="datetimeFigureOut">
               <a:rPr lang="en-US" smtClean="0"/>
-              <a:t>1/27/13</a:t>
+              <a:t>6/7/26</a:t>
             </a:fld>
             <a:endParaRPr lang="en-US"/>
           </a:p>
@@ -2094,10 +2094,9 @@
           </a:lstStyle>
           <a:p>
             <a:r>
-              <a:rPr lang="en-US" smtClean="0"/>
+              <a:rPr lang="en-US"/>
               <a:t>Click to edit Master title style</a:t>
             </a:r>
-            <a:endParaRPr lang="en-US"/>
           </a:p>
         </p:txBody>
       </p:sp>
@@ -2151,38 +2150,37 @@
           <a:p>
             <a:pPr lvl="0"/>
             <a:r>
-              <a:rPr lang="en-US" smtClean="0"/>
+              <a:rPr lang="en-US"/>
               <a:t>Click to edit Master text styles</a:t>
             </a:r>
           </a:p>
           <a:p>
             <a:pPr lvl="1"/>
             <a:r>
-              <a:rPr lang="en-US" smtClean="0"/>
+              <a:rPr lang="en-US"/>
               <a:t>Second level</a:t>
             </a:r>
           </a:p>
           <a:p>
             <a:pPr lvl="2"/>
             <a:r>
-              <a:rPr lang="en-US" smtClean="0"/>
+              <a:rPr lang="en-US"/>
               <a:t>Third level</a:t>
             </a:r>
           </a:p>
           <a:p>
             <a:pPr lvl="3"/>
             <a:r>
-              <a:rPr lang="en-US" smtClean="0"/>
+              <a:rPr lang="en-US"/>
               <a:t>Fourth level</a:t>
             </a:r>
           </a:p>
           <a:p>
             <a:pPr lvl="4"/>
             <a:r>
-              <a:rPr lang="en-US" smtClean="0"/>
+              <a:rPr lang="en-US"/>
               <a:t>Fifth level</a:t>
             </a:r>
-            <a:endParaRPr lang="en-US"/>
           </a:p>
         </p:txBody>
       </p:sp>
@@ -2245,7 +2243,7 @@
           <a:p>
             <a:pPr lvl="0"/>
             <a:r>
-              <a:rPr lang="en-US" smtClean="0"/>
+              <a:rPr lang="en-US"/>
               <a:t>Click to edit Master text styles</a:t>
             </a:r>
           </a:p>
@@ -2268,7 +2266,7 @@
           <a:p>
             <a:fld id="{5BCAD085-E8A6-8845-BD4E-CB4CCA059FC4}" type="datetimeFigureOut">
               <a:rPr lang="en-US" smtClean="0"/>
-              <a:t>1/27/13</a:t>
+              <a:t>6/7/26</a:t>
             </a:fld>
             <a:endParaRPr lang="en-US"/>
           </a:p>
@@ -2371,10 +2369,9 @@
           </a:lstStyle>
           <a:p>
             <a:r>
-              <a:rPr lang="en-US" smtClean="0"/>
+              <a:rPr lang="en-US"/>
               <a:t>Click to edit Master title style</a:t>
             </a:r>
-            <a:endParaRPr lang="en-US"/>
           </a:p>
         </p:txBody>
       </p:sp>
@@ -2498,7 +2495,7 @@
           <a:p>
             <a:pPr lvl="0"/>
             <a:r>
-              <a:rPr lang="en-US" smtClean="0"/>
+              <a:rPr lang="en-US"/>
               <a:t>Click to edit Master text styles</a:t>
             </a:r>
           </a:p>
@@ -2521,7 +2518,7 @@
           <a:p>
             <a:fld id="{5BCAD085-E8A6-8845-BD4E-CB4CCA059FC4}" type="datetimeFigureOut">
               <a:rPr lang="en-US" smtClean="0"/>
-              <a:t>1/27/13</a:t>
+              <a:t>6/7/26</a:t>
             </a:fld>
             <a:endParaRPr lang="en-US"/>
           </a:p>
@@ -2630,10 +2627,9 @@
           <a:lstStyle/>
           <a:p>
             <a:r>
-              <a:rPr lang="en-US" smtClean="0"/>
+              <a:rPr lang="en-US"/>
               <a:t>Click to edit Master title style</a:t>
             </a:r>
-            <a:endParaRPr lang="en-US"/>
           </a:p>
         </p:txBody>
       </p:sp>
@@ -2664,38 +2660,37 @@
           <a:p>
             <a:pPr lvl="0"/>
             <a:r>
-              <a:rPr lang="en-US" smtClean="0"/>
+              <a:rPr lang="en-US"/>
               <a:t>Click to edit Master text styles</a:t>
             </a:r>
           </a:p>
           <a:p>
             <a:pPr lvl="1"/>
             <a:r>
-              <a:rPr lang="en-US" smtClean="0"/>
+              <a:rPr lang="en-US"/>
               <a:t>Second level</a:t>
             </a:r>
           </a:p>
           <a:p>
             <a:pPr lvl="2"/>
             <a:r>
-              <a:rPr lang="en-US" smtClean="0"/>
+              <a:rPr lang="en-US"/>
               <a:t>Third level</a:t>
             </a:r>
           </a:p>
           <a:p>
             <a:pPr lvl="3"/>
             <a:r>
-              <a:rPr lang="en-US" smtClean="0"/>
+              <a:rPr lang="en-US"/>
               <a:t>Fourth level</a:t>
             </a:r>
           </a:p>
           <a:p>
             <a:pPr lvl="4"/>
             <a:r>
-              <a:rPr lang="en-US" smtClean="0"/>
+              <a:rPr lang="en-US"/>
               <a:t>Fifth level</a:t>
             </a:r>
-            <a:endParaRPr lang="en-US"/>
           </a:p>
         </p:txBody>
       </p:sp>
@@ -2734,7 +2729,7 @@
           <a:p>
             <a:fld id="{5BCAD085-E8A6-8845-BD4E-CB4CCA059FC4}" type="datetimeFigureOut">
               <a:rPr lang="en-US" smtClean="0"/>
-              <a:t>1/27/13</a:t>
+              <a:t>6/7/26</a:t>
             </a:fld>
             <a:endParaRPr lang="en-US"/>
           </a:p>
@@ -3093,7 +3088,7 @@
 </file>
 
 <file path=ppt/slides/slide1.xml><?xml version="1.0" encoding="utf-8"?>
-<p:sld xmlns:a="http://schemas.openxmlformats.org/drawingml/2006/main" xmlns:p="http://schemas.openxmlformats.org/presentationml/2006/main" xmlns:r="http://schemas.openxmlformats.org/officeDocument/2006/relationships">
+<p:sld xmlns:a="http://schemas.openxmlformats.org/drawingml/2006/main" xmlns:r="http://schemas.openxmlformats.org/officeDocument/2006/relationships" xmlns:p="http://schemas.openxmlformats.org/presentationml/2006/main">
   <p:cSld>
     <p:spTree>
       <p:nvGrpSpPr>
@@ -3101,7 +3096,14 @@
         <p:cNvGrpSpPr/>
         <p:nvPr/>
       </p:nvGrpSpPr>
-      <p:grpSpPr/>
+      <p:grpSpPr>
+        <a:xfrm>
+          <a:off x="0" y="0"/>
+          <a:ext cx="0" cy="0"/>
+          <a:chOff x="0" y="0"/>
+          <a:chExt cx="0" cy="0"/>
+        </a:xfrm>
+      </p:grpSpPr>
       <p:sp>
         <p:nvSpPr>
           <p:cNvPr id="2" name="Rectangle 1"/>
@@ -3142,6 +3144,7 @@
           <a:lstStyle/>
           <a:p>
             <a:pPr algn="ctr"/>
+            <a:endParaRPr/>
           </a:p>
         </p:txBody>
       </p:sp>
@@ -3185,6 +3188,7 @@
           <a:lstStyle/>
           <a:p>
             <a:pPr algn="ctr"/>
+            <a:endParaRPr/>
           </a:p>
         </p:txBody>
       </p:sp>
@@ -3228,6 +3232,7 @@
           <a:lstStyle/>
           <a:p>
             <a:pPr algn="ctr"/>
+            <a:endParaRPr/>
           </a:p>
         </p:txBody>
       </p:sp>
@@ -3271,6 +3276,7 @@
           <a:lstStyle/>
           <a:p>
             <a:pPr algn="ctr"/>
+            <a:endParaRPr/>
           </a:p>
         </p:txBody>
       </p:sp>
@@ -3477,7 +3483,7 @@
 </file>
 
 <file path=ppt/slides/slide10.xml><?xml version="1.0" encoding="utf-8"?>
-<p:sld xmlns:a="http://schemas.openxmlformats.org/drawingml/2006/main" xmlns:p="http://schemas.openxmlformats.org/presentationml/2006/main" xmlns:r="http://schemas.openxmlformats.org/officeDocument/2006/relationships">
+<p:sld xmlns:a="http://schemas.openxmlformats.org/drawingml/2006/main" xmlns:r="http://schemas.openxmlformats.org/officeDocument/2006/relationships" xmlns:p="http://schemas.openxmlformats.org/presentationml/2006/main">
   <p:cSld>
     <p:spTree>
       <p:nvGrpSpPr>
@@ -3485,7 +3491,14 @@
         <p:cNvGrpSpPr/>
         <p:nvPr/>
       </p:nvGrpSpPr>
-      <p:grpSpPr/>
+      <p:grpSpPr>
+        <a:xfrm>
+          <a:off x="0" y="0"/>
+          <a:ext cx="0" cy="0"/>
+          <a:chOff x="0" y="0"/>
+          <a:chExt cx="0" cy="0"/>
+        </a:xfrm>
+      </p:grpSpPr>
       <p:sp>
         <p:nvSpPr>
           <p:cNvPr id="2" name="Rectangle 1"/>
@@ -3526,6 +3539,7 @@
           <a:lstStyle/>
           <a:p>
             <a:pPr algn="ctr"/>
+            <a:endParaRPr/>
           </a:p>
         </p:txBody>
       </p:sp>
@@ -3569,6 +3583,7 @@
           <a:lstStyle/>
           <a:p>
             <a:pPr algn="ctr"/>
+            <a:endParaRPr/>
           </a:p>
         </p:txBody>
       </p:sp>
@@ -3670,6 +3685,7 @@
           <a:lstStyle/>
           <a:p>
             <a:pPr algn="ctr"/>
+            <a:endParaRPr/>
           </a:p>
         </p:txBody>
       </p:sp>
@@ -3713,6 +3729,7 @@
           <a:lstStyle/>
           <a:p>
             <a:pPr algn="ctr"/>
+            <a:endParaRPr/>
           </a:p>
         </p:txBody>
       </p:sp>
@@ -3759,7 +3776,7 @@
         <p:spPr>
           <a:xfrm>
             <a:off x="502920" y="2148840"/>
-            <a:ext cx="5029200" cy="3931920"/>
+            <a:ext cx="5029200" cy="3177793"/>
           </a:xfrm>
           <a:prstGeom prst="rect">
             <a:avLst/>
@@ -3771,7 +3788,9 @@
             <a:spAutoFit/>
           </a:bodyPr>
           <a:lstStyle/>
-          <a:p/>
+          <a:p>
+            <a:endParaRPr dirty="0"/>
+          </a:p>
           <a:p>
             <a:pPr algn="l">
               <a:spcBef>
@@ -3779,12 +3798,28 @@
               </a:spcBef>
             </a:pPr>
             <a:r>
-              <a:rPr sz="1300" b="0" i="0">
-                <a:solidFill>
-                  <a:srgbClr val="D0D8E8"/>
-                </a:solidFill>
-              </a:rPr>
-              <a:t>·  Frontend — UI-ontwerp, Jinja2-templates, Bootstrap 5-layout</a:t>
+              <a:rPr sz="1300" b="0" i="0" dirty="0">
+                <a:solidFill>
+                  <a:srgbClr val="D0D8E8"/>
+                </a:solidFill>
+              </a:rPr>
+              <a:t>·  Frontend — UI-</a:t>
+            </a:r>
+            <a:r>
+              <a:rPr sz="1300" b="0" i="0" dirty="0" err="1">
+                <a:solidFill>
+                  <a:srgbClr val="D0D8E8"/>
+                </a:solidFill>
+              </a:rPr>
+              <a:t>ontwerp</a:t>
+            </a:r>
+            <a:r>
+              <a:rPr sz="1300" b="0" i="0" dirty="0">
+                <a:solidFill>
+                  <a:srgbClr val="D0D8E8"/>
+                </a:solidFill>
+              </a:rPr>
+              <a:t>, Jinja2-templates, Bootstrap 5-layout</a:t>
             </a:r>
           </a:p>
           <a:p>
@@ -3794,12 +3829,76 @@
               </a:spcBef>
             </a:pPr>
             <a:r>
-              <a:rPr sz="1300" b="0" i="0">
-                <a:solidFill>
-                  <a:srgbClr val="D0D8E8"/>
-                </a:solidFill>
-              </a:rPr>
-              <a:t>·  Visualisaties — Plotly-grafieken (staaf, taart, heatmap)</a:t>
+              <a:rPr sz="1300" b="0" i="0" dirty="0">
+                <a:solidFill>
+                  <a:srgbClr val="D0D8E8"/>
+                </a:solidFill>
+              </a:rPr>
+              <a:t>·  </a:t>
+            </a:r>
+            <a:r>
+              <a:rPr sz="1300" b="0" i="0" dirty="0" err="1">
+                <a:solidFill>
+                  <a:srgbClr val="D0D8E8"/>
+                </a:solidFill>
+              </a:rPr>
+              <a:t>Visualisaties</a:t>
+            </a:r>
+            <a:r>
+              <a:rPr sz="1300" b="0" i="0" dirty="0">
+                <a:solidFill>
+                  <a:srgbClr val="D0D8E8"/>
+                </a:solidFill>
+              </a:rPr>
+              <a:t> — </a:t>
+            </a:r>
+            <a:r>
+              <a:rPr sz="1300" b="0" i="0" dirty="0" err="1">
+                <a:solidFill>
+                  <a:srgbClr val="D0D8E8"/>
+                </a:solidFill>
+              </a:rPr>
+              <a:t>Plotly-grafieken</a:t>
+            </a:r>
+            <a:r>
+              <a:rPr sz="1300" b="0" i="0" dirty="0">
+                <a:solidFill>
+                  <a:srgbClr val="D0D8E8"/>
+                </a:solidFill>
+              </a:rPr>
+              <a:t> (</a:t>
+            </a:r>
+            <a:r>
+              <a:rPr sz="1300" b="0" i="0" dirty="0" err="1">
+                <a:solidFill>
+                  <a:srgbClr val="D0D8E8"/>
+                </a:solidFill>
+              </a:rPr>
+              <a:t>staaf</a:t>
+            </a:r>
+            <a:r>
+              <a:rPr sz="1300" b="0" i="0" dirty="0">
+                <a:solidFill>
+                  <a:srgbClr val="D0D8E8"/>
+                </a:solidFill>
+              </a:rPr>
+              <a:t>, </a:t>
+            </a:r>
+            <a:r>
+              <a:rPr sz="1300" b="0" i="0" dirty="0" err="1">
+                <a:solidFill>
+                  <a:srgbClr val="D0D8E8"/>
+                </a:solidFill>
+              </a:rPr>
+              <a:t>taart</a:t>
+            </a:r>
+            <a:r>
+              <a:rPr sz="1300" b="0" i="0" dirty="0">
+                <a:solidFill>
+                  <a:srgbClr val="D0D8E8"/>
+                </a:solidFill>
+              </a:rPr>
+              <a:t>, heatmap)</a:t>
             </a:r>
           </a:p>
           <a:p>
@@ -3809,13 +3908,42 @@
               </a:spcBef>
             </a:pPr>
             <a:r>
-              <a:rPr sz="1300" b="0" i="0">
-                <a:solidFill>
-                  <a:srgbClr val="D0D8E8"/>
-                </a:solidFill>
-              </a:rPr>
-              <a:t>·  Flask-routes, Blueprint-structuur, formulierafhandeling</a:t>
-            </a:r>
+              <a:rPr sz="1300" b="0" i="0" dirty="0">
+                <a:solidFill>
+                  <a:srgbClr val="D0D8E8"/>
+                </a:solidFill>
+              </a:rPr>
+              <a:t>·  Flask-routes, Blueprint-</a:t>
+            </a:r>
+            <a:r>
+              <a:rPr sz="1300" b="0" i="0" dirty="0" err="1">
+                <a:solidFill>
+                  <a:srgbClr val="D0D8E8"/>
+                </a:solidFill>
+              </a:rPr>
+              <a:t>structuur</a:t>
+            </a:r>
+            <a:r>
+              <a:rPr sz="1300" b="0" i="0" dirty="0">
+                <a:solidFill>
+                  <a:srgbClr val="D0D8E8"/>
+                </a:solidFill>
+              </a:rPr>
+              <a:t>, </a:t>
+            </a:r>
+            <a:r>
+              <a:rPr sz="1300" b="0" i="0" dirty="0" err="1">
+                <a:solidFill>
+                  <a:srgbClr val="D0D8E8"/>
+                </a:solidFill>
+              </a:rPr>
+              <a:t>formulierafhandeling</a:t>
+            </a:r>
+            <a:endParaRPr sz="1300" b="0" i="0" dirty="0">
+              <a:solidFill>
+                <a:srgbClr val="D0D8E8"/>
+              </a:solidFill>
+            </a:endParaRPr>
           </a:p>
           <a:p>
             <a:pPr algn="l">
@@ -3824,13 +3952,58 @@
               </a:spcBef>
             </a:pPr>
             <a:r>
-              <a:rPr sz="1300" b="0" i="0">
-                <a:solidFill>
-                  <a:srgbClr val="D0D8E8"/>
-                </a:solidFill>
-              </a:rPr>
-              <a:t>·  PDF-export — DiagramPdfService, Kaleido + ReportLab</a:t>
-            </a:r>
+              <a:rPr sz="1300" b="0" i="0" dirty="0">
+                <a:solidFill>
+                  <a:srgbClr val="D0D8E8"/>
+                </a:solidFill>
+              </a:rPr>
+              <a:t>·  PDF-export — </a:t>
+            </a:r>
+            <a:r>
+              <a:rPr sz="1300" b="0" i="0" dirty="0" err="1">
+                <a:solidFill>
+                  <a:srgbClr val="D0D8E8"/>
+                </a:solidFill>
+              </a:rPr>
+              <a:t>DiagramPdfService</a:t>
+            </a:r>
+            <a:r>
+              <a:rPr sz="1300" b="0" i="0" dirty="0">
+                <a:solidFill>
+                  <a:srgbClr val="D0D8E8"/>
+                </a:solidFill>
+              </a:rPr>
+              <a:t>, </a:t>
+            </a:r>
+            <a:r>
+              <a:rPr sz="1300" b="0" i="0" dirty="0" err="1">
+                <a:solidFill>
+                  <a:srgbClr val="D0D8E8"/>
+                </a:solidFill>
+              </a:rPr>
+              <a:t>Kaleido</a:t>
+            </a:r>
+            <a:r>
+              <a:rPr sz="1300" b="0" i="0" dirty="0">
+                <a:solidFill>
+                  <a:srgbClr val="D0D8E8"/>
+                </a:solidFill>
+              </a:rPr>
+              <a:t> + </a:t>
+            </a:r>
+            <a:r>
+              <a:rPr sz="1300" b="0" i="0" dirty="0" err="1">
+                <a:solidFill>
+                  <a:srgbClr val="D0D8E8"/>
+                </a:solidFill>
+              </a:rPr>
+              <a:t>ReportLab</a:t>
+            </a:r>
+            <a:endParaRPr sz="1300" b="0" i="0" dirty="0">
+              <a:solidFill>
+                <a:srgbClr val="D0D8E8"/>
+              </a:solidFill>
+            </a:endParaRPr>
           </a:p>
           <a:p>
             <a:pPr algn="l">
@@ -3839,12 +4012,44 @@
               </a:spcBef>
             </a:pPr>
             <a:r>
-              <a:rPr sz="1300" b="0" i="0">
-                <a:solidFill>
-                  <a:srgbClr val="D0D8E8"/>
-                </a:solidFill>
-              </a:rPr>
-              <a:t>·  JavaScript: inklapbare boom, async PDF-download, globale spinner</a:t>
+              <a:rPr sz="1300" b="0" i="0" dirty="0">
+                <a:solidFill>
+                  <a:srgbClr val="D0D8E8"/>
+                </a:solidFill>
+              </a:rPr>
+              <a:t>·  JavaScript: </a:t>
+            </a:r>
+            <a:r>
+              <a:rPr sz="1300" b="0" i="0" dirty="0" err="1">
+                <a:solidFill>
+                  <a:srgbClr val="D0D8E8"/>
+                </a:solidFill>
+              </a:rPr>
+              <a:t>inklapbare</a:t>
+            </a:r>
+            <a:r>
+              <a:rPr sz="1300" b="0" i="0" dirty="0">
+                <a:solidFill>
+                  <a:srgbClr val="D0D8E8"/>
+                </a:solidFill>
+              </a:rPr>
+              <a:t> boom, async PDF-download, </a:t>
+            </a:r>
+            <a:r>
+              <a:rPr sz="1300" b="0" i="0" dirty="0" err="1">
+                <a:solidFill>
+                  <a:srgbClr val="D0D8E8"/>
+                </a:solidFill>
+              </a:rPr>
+              <a:t>globale</a:t>
+            </a:r>
+            <a:r>
+              <a:rPr sz="1300" b="0" i="0" dirty="0">
+                <a:solidFill>
+                  <a:srgbClr val="D0D8E8"/>
+                </a:solidFill>
+              </a:rPr>
+              <a:t> spinner</a:t>
             </a:r>
           </a:p>
           <a:p>
@@ -3854,12 +4059,180 @@
               </a:spcBef>
             </a:pPr>
             <a:r>
-              <a:rPr sz="1300" b="0" i="0">
-                <a:solidFill>
-                  <a:srgbClr val="D0D8E8"/>
-                </a:solidFill>
-              </a:rPr>
-              <a:t>·  Documentatie: README, CHANGELOG, PROJECT_PROGRESS, architectuurdocs</a:t>
+              <a:rPr sz="1300" b="0" i="0" dirty="0">
+                <a:solidFill>
+                  <a:srgbClr val="D0D8E8"/>
+                </a:solidFill>
+              </a:rPr>
+              <a:t>·  </a:t>
+            </a:r>
+            <a:r>
+              <a:rPr sz="1300" b="0" i="0" dirty="0" err="1">
+                <a:solidFill>
+                  <a:srgbClr val="D0D8E8"/>
+                </a:solidFill>
+              </a:rPr>
+              <a:t>Documentatie</a:t>
+            </a:r>
+            <a:r>
+              <a:rPr sz="1300" b="0" i="0" dirty="0">
+                <a:solidFill>
+                  <a:srgbClr val="D0D8E8"/>
+                </a:solidFill>
+              </a:rPr>
+              <a:t>: README, CHANGELOG, PROJECT_PROGRESS, </a:t>
+            </a:r>
+            <a:r>
+              <a:rPr sz="1300" b="0" i="0" dirty="0" err="1">
+                <a:solidFill>
+                  <a:srgbClr val="D0D8E8"/>
+                </a:solidFill>
+              </a:rPr>
+              <a:t>architectuurdocs</a:t>
+            </a:r>
+            <a:endParaRPr sz="1300" b="0" i="0" dirty="0">
+              <a:solidFill>
+                <a:srgbClr val="D0D8E8"/>
+              </a:solidFill>
+            </a:endParaRPr>
+          </a:p>
+          <a:p>
+            <a:pPr>
+              <a:spcBef>
+                <a:spcPts val="700"/>
+              </a:spcBef>
+            </a:pPr>
+            <a:r>
+              <a:rPr sz="1300" b="0" i="0" dirty="0">
+                <a:solidFill>
+                  <a:srgbClr val="D0D8E8"/>
+                </a:solidFill>
+              </a:rPr>
+              <a:t>·  </a:t>
+            </a:r>
+            <a:r>
+              <a:rPr sz="1300" b="0" i="0" dirty="0" err="1">
+                <a:solidFill>
+                  <a:srgbClr val="D0D8E8"/>
+                </a:solidFill>
+              </a:rPr>
+              <a:t>Performantie</a:t>
+            </a:r>
+            <a:r>
+              <a:rPr sz="1300" b="0" i="0" dirty="0">
+                <a:solidFill>
+                  <a:srgbClr val="D0D8E8"/>
+                </a:solidFill>
+              </a:rPr>
+              <a:t>: query-</a:t>
+            </a:r>
+            <a:r>
+              <a:rPr sz="1300" b="0" i="0" dirty="0" err="1">
+                <a:solidFill>
+                  <a:srgbClr val="D0D8E8"/>
+                </a:solidFill>
+              </a:rPr>
+              <a:t>herschrijvingen</a:t>
+            </a:r>
+            <a:r>
+              <a:rPr sz="1300" b="0" i="0" dirty="0">
+                <a:solidFill>
+                  <a:srgbClr val="D0D8E8"/>
+                </a:solidFill>
+              </a:rPr>
+              <a:t> </a:t>
+            </a:r>
+            <a:r>
+              <a:rPr sz="1300" b="0" i="0" dirty="0" err="1">
+                <a:solidFill>
+                  <a:srgbClr val="D0D8E8"/>
+                </a:solidFill>
+              </a:rPr>
+              <a:t>en</a:t>
+            </a:r>
+            <a:r>
+              <a:rPr sz="1300" b="0" i="0" dirty="0">
+                <a:solidFill>
+                  <a:srgbClr val="D0D8E8"/>
+                </a:solidFill>
+              </a:rPr>
+              <a:t> DB-</a:t>
+            </a:r>
+            <a:r>
+              <a:rPr sz="1300" b="0" i="0" dirty="0" err="1">
+                <a:solidFill>
+                  <a:srgbClr val="D0D8E8"/>
+                </a:solidFill>
+              </a:rPr>
+              <a:t>indextuning</a:t>
+            </a:r>
+            <a:endParaRPr lang="nl-BE" sz="1300" b="0" i="0" dirty="0">
+              <a:solidFill>
+                <a:srgbClr val="D0D8E8"/>
+              </a:solidFill>
+            </a:endParaRPr>
+          </a:p>
+          <a:p>
+            <a:pPr>
+              <a:spcBef>
+                <a:spcPts val="700"/>
+              </a:spcBef>
+            </a:pPr>
+            <a:r>
+              <a:rPr lang="en-US" sz="1300" dirty="0">
+                <a:solidFill>
+                  <a:srgbClr val="D0D8E8"/>
+                </a:solidFill>
+              </a:rPr>
+              <a:t>· </a:t>
+            </a:r>
+            <a:r>
+              <a:rPr lang="en-US" sz="1300" dirty="0" err="1">
+                <a:solidFill>
+                  <a:srgbClr val="D0D8E8"/>
+                </a:solidFill>
+              </a:rPr>
+              <a:t>MailService</a:t>
+            </a:r>
+            <a:r>
+              <a:rPr lang="en-US" sz="1300" dirty="0">
+                <a:solidFill>
+                  <a:srgbClr val="D0D8E8"/>
+                </a:solidFill>
+              </a:rPr>
+              <a:t>: </a:t>
+            </a:r>
+            <a:r>
+              <a:rPr lang="en-US" sz="1300" dirty="0" err="1">
+                <a:solidFill>
+                  <a:srgbClr val="D0D8E8"/>
+                </a:solidFill>
+              </a:rPr>
+              <a:t>geautomatiseerde</a:t>
+            </a:r>
+            <a:r>
+              <a:rPr lang="en-US" sz="1300" dirty="0">
+                <a:solidFill>
+                  <a:srgbClr val="D0D8E8"/>
+                </a:solidFill>
+              </a:rPr>
+              <a:t> e-</a:t>
+            </a:r>
+            <a:r>
+              <a:rPr lang="en-US" sz="1300" dirty="0" err="1">
+                <a:solidFill>
+                  <a:srgbClr val="D0D8E8"/>
+                </a:solidFill>
+              </a:rPr>
+              <a:t>mailrapporten</a:t>
+            </a:r>
+            <a:r>
+              <a:rPr lang="en-US" sz="1300" dirty="0">
+                <a:solidFill>
+                  <a:srgbClr val="D0D8E8"/>
+                </a:solidFill>
+              </a:rPr>
+              <a:t> via SMTP</a:t>
             </a:r>
           </a:p>
           <a:p>
@@ -3868,14 +4241,11 @@
                 <a:spcPts val="700"/>
               </a:spcBef>
             </a:pPr>
-            <a:r>
-              <a:rPr sz="1300" b="0" i="0">
-                <a:solidFill>
-                  <a:srgbClr val="D0D8E8"/>
-                </a:solidFill>
-              </a:rPr>
-              <a:t>·  Performantie: query-herschrijvingen en DB-indextuning</a:t>
-            </a:r>
+            <a:endParaRPr sz="1300" b="0" i="0" dirty="0">
+              <a:solidFill>
+                <a:srgbClr val="D0D8E8"/>
+              </a:solidFill>
+            </a:endParaRPr>
           </a:p>
         </p:txBody>
       </p:sp>
@@ -3919,6 +4289,7 @@
           <a:lstStyle/>
           <a:p>
             <a:pPr algn="ctr"/>
+            <a:endParaRPr/>
           </a:p>
         </p:txBody>
       </p:sp>
@@ -3962,6 +4333,7 @@
           <a:lstStyle/>
           <a:p>
             <a:pPr algn="ctr"/>
+            <a:endParaRPr/>
           </a:p>
         </p:txBody>
       </p:sp>
@@ -4008,7 +4380,7 @@
         <p:spPr>
           <a:xfrm>
             <a:off x="6172200" y="2148840"/>
-            <a:ext cx="5486400" cy="3931920"/>
+            <a:ext cx="5486400" cy="2108269"/>
           </a:xfrm>
           <a:prstGeom prst="rect">
             <a:avLst/>
@@ -4020,7 +4392,9 @@
             <a:spAutoFit/>
           </a:bodyPr>
           <a:lstStyle/>
-          <a:p/>
+          <a:p>
+            <a:endParaRPr dirty="0"/>
+          </a:p>
           <a:p>
             <a:pPr algn="l">
               <a:spcBef>
@@ -4028,13 +4402,58 @@
               </a:spcBef>
             </a:pPr>
             <a:r>
-              <a:rPr sz="1300" b="0" i="0">
-                <a:solidFill>
-                  <a:srgbClr val="D0D8E8"/>
-                </a:solidFill>
-              </a:rPr>
-              <a:t>·  Backend — databaseontwerp en normalisatie</a:t>
-            </a:r>
+              <a:rPr sz="1300" b="0" i="0" dirty="0">
+                <a:solidFill>
+                  <a:srgbClr val="D0D8E8"/>
+                </a:solidFill>
+              </a:rPr>
+              <a:t>·  Backend — </a:t>
+            </a:r>
+            <a:r>
+              <a:rPr sz="1300" b="0" i="0" dirty="0" err="1">
+                <a:solidFill>
+                  <a:srgbClr val="D0D8E8"/>
+                </a:solidFill>
+              </a:rPr>
+              <a:t>databaseontwerp</a:t>
+            </a:r>
+            <a:r>
+              <a:rPr sz="1300" b="0" i="0" dirty="0">
+                <a:solidFill>
+                  <a:srgbClr val="D0D8E8"/>
+                </a:solidFill>
+              </a:rPr>
+              <a:t> </a:t>
+            </a:r>
+            <a:r>
+              <a:rPr sz="1300" b="0" i="0" dirty="0" err="1">
+                <a:solidFill>
+                  <a:srgbClr val="D0D8E8"/>
+                </a:solidFill>
+              </a:rPr>
+              <a:t>en</a:t>
+            </a:r>
+            <a:r>
+              <a:rPr sz="1300" b="0" i="0" dirty="0">
+                <a:solidFill>
+                  <a:srgbClr val="D0D8E8"/>
+                </a:solidFill>
+              </a:rPr>
+              <a:t> </a:t>
+            </a:r>
+            <a:r>
+              <a:rPr sz="1300" b="0" i="0" dirty="0" err="1">
+                <a:solidFill>
+                  <a:srgbClr val="D0D8E8"/>
+                </a:solidFill>
+              </a:rPr>
+              <a:t>normalisatie</a:t>
+            </a:r>
+            <a:endParaRPr sz="1300" b="0" i="0" dirty="0">
+              <a:solidFill>
+                <a:srgbClr val="D0D8E8"/>
+              </a:solidFill>
+            </a:endParaRPr>
           </a:p>
           <a:p>
             <a:pPr algn="l">
@@ -4043,13 +4462,26 @@
               </a:spcBef>
             </a:pPr>
             <a:r>
-              <a:rPr sz="1300" b="0" i="0">
-                <a:solidFill>
-                  <a:srgbClr val="D0D8E8"/>
-                </a:solidFill>
-              </a:rPr>
-              <a:t>·  SQL Server: TVF's, stored procedures, views, indexen</a:t>
-            </a:r>
+              <a:rPr sz="1300" b="0" i="0" dirty="0">
+                <a:solidFill>
+                  <a:srgbClr val="D0D8E8"/>
+                </a:solidFill>
+              </a:rPr>
+              <a:t>·  SQL Server: TVF's, stored procedures, views, </a:t>
+            </a:r>
+            <a:r>
+              <a:rPr sz="1300" b="0" i="0" dirty="0" err="1">
+                <a:solidFill>
+                  <a:srgbClr val="D0D8E8"/>
+                </a:solidFill>
+              </a:rPr>
+              <a:t>indexen</a:t>
+            </a:r>
+            <a:endParaRPr sz="1300" b="0" i="0" dirty="0">
+              <a:solidFill>
+                <a:srgbClr val="D0D8E8"/>
+              </a:solidFill>
+            </a:endParaRPr>
           </a:p>
           <a:p>
             <a:pPr algn="l">
@@ -4058,13 +4490,74 @@
               </a:spcBef>
             </a:pPr>
             <a:r>
-              <a:rPr sz="1300" b="0" i="0">
-                <a:solidFill>
-                  <a:srgbClr val="D0D8E8"/>
-                </a:solidFill>
-              </a:rPr>
-              <a:t>·  SQLAlchemy ORM-modellen en repository-laag</a:t>
-            </a:r>
+              <a:rPr sz="1300" b="0" i="0" dirty="0">
+                <a:solidFill>
+                  <a:srgbClr val="D0D8E8"/>
+                </a:solidFill>
+              </a:rPr>
+              <a:t>·  </a:t>
+            </a:r>
+            <a:r>
+              <a:rPr sz="1300" b="0" i="0" dirty="0" err="1">
+                <a:solidFill>
+                  <a:srgbClr val="D0D8E8"/>
+                </a:solidFill>
+              </a:rPr>
+              <a:t>SQLAlchemy</a:t>
+            </a:r>
+            <a:r>
+              <a:rPr sz="1300" b="0" i="0" dirty="0">
+                <a:solidFill>
+                  <a:srgbClr val="D0D8E8"/>
+                </a:solidFill>
+              </a:rPr>
+              <a:t> ORM-</a:t>
+            </a:r>
+            <a:r>
+              <a:rPr sz="1300" b="0" i="0" dirty="0" err="1">
+                <a:solidFill>
+                  <a:srgbClr val="D0D8E8"/>
+                </a:solidFill>
+              </a:rPr>
+              <a:t>modellen</a:t>
+            </a:r>
+            <a:r>
+              <a:rPr sz="1300" b="0" i="0" dirty="0">
+                <a:solidFill>
+                  <a:srgbClr val="D0D8E8"/>
+                </a:solidFill>
+              </a:rPr>
+              <a:t> </a:t>
+            </a:r>
+            <a:r>
+              <a:rPr sz="1300" b="0" i="0" dirty="0" err="1">
+                <a:solidFill>
+                  <a:srgbClr val="D0D8E8"/>
+                </a:solidFill>
+              </a:rPr>
+              <a:t>en</a:t>
+            </a:r>
+            <a:r>
+              <a:rPr sz="1300" b="0" i="0" dirty="0">
+                <a:solidFill>
+                  <a:srgbClr val="D0D8E8"/>
+                </a:solidFill>
+              </a:rPr>
+              <a:t> repository-</a:t>
+            </a:r>
+            <a:r>
+              <a:rPr sz="1300" b="0" i="0" dirty="0" err="1">
+                <a:solidFill>
+                  <a:srgbClr val="D0D8E8"/>
+                </a:solidFill>
+              </a:rPr>
+              <a:t>laag</a:t>
+            </a:r>
+            <a:endParaRPr sz="1300" b="0" i="0" dirty="0">
+              <a:solidFill>
+                <a:srgbClr val="D0D8E8"/>
+              </a:solidFill>
+            </a:endParaRPr>
           </a:p>
           <a:p>
             <a:pPr algn="l">
@@ -4073,13 +4566,58 @@
               </a:spcBef>
             </a:pPr>
             <a:r>
-              <a:rPr sz="1300" b="0" i="0">
-                <a:solidFill>
-                  <a:srgbClr val="D0D8E8"/>
-                </a:solidFill>
-              </a:rPr>
-              <a:t>·  InterlockService: motor voor grondoorzaak-ketenanalyse</a:t>
-            </a:r>
+              <a:rPr sz="1300" b="0" i="0" dirty="0">
+                <a:solidFill>
+                  <a:srgbClr val="D0D8E8"/>
+                </a:solidFill>
+              </a:rPr>
+              <a:t>·  </a:t>
+            </a:r>
+            <a:r>
+              <a:rPr sz="1300" b="0" i="0" dirty="0" err="1">
+                <a:solidFill>
+                  <a:srgbClr val="D0D8E8"/>
+                </a:solidFill>
+              </a:rPr>
+              <a:t>InterlockService</a:t>
+            </a:r>
+            <a:r>
+              <a:rPr sz="1300" b="0" i="0" dirty="0">
+                <a:solidFill>
+                  <a:srgbClr val="D0D8E8"/>
+                </a:solidFill>
+              </a:rPr>
+              <a:t>: motor </a:t>
+            </a:r>
+            <a:r>
+              <a:rPr sz="1300" b="0" i="0" dirty="0" err="1">
+                <a:solidFill>
+                  <a:srgbClr val="D0D8E8"/>
+                </a:solidFill>
+              </a:rPr>
+              <a:t>voor</a:t>
+            </a:r>
+            <a:r>
+              <a:rPr sz="1300" b="0" i="0" dirty="0">
+                <a:solidFill>
+                  <a:srgbClr val="D0D8E8"/>
+                </a:solidFill>
+              </a:rPr>
+              <a:t> </a:t>
+            </a:r>
+            <a:r>
+              <a:rPr sz="1300" b="0" i="0" dirty="0" err="1">
+                <a:solidFill>
+                  <a:srgbClr val="D0D8E8"/>
+                </a:solidFill>
+              </a:rPr>
+              <a:t>grondoorzaak-ketenanalyse</a:t>
+            </a:r>
+            <a:endParaRPr sz="1300" b="0" i="0" dirty="0">
+              <a:solidFill>
+                <a:srgbClr val="D0D8E8"/>
+              </a:solidFill>
+            </a:endParaRPr>
           </a:p>
           <a:p>
             <a:pPr algn="l">
@@ -4088,12 +4626,60 @@
               </a:spcBef>
             </a:pPr>
             <a:r>
-              <a:rPr sz="1300" b="0" i="0">
-                <a:solidFill>
-                  <a:srgbClr val="D0D8E8"/>
-                </a:solidFill>
-              </a:rPr>
-              <a:t>·  Snapshot-systeem: wekelijkse storingssnapshots + backfill-scripts</a:t>
+              <a:rPr sz="1300" b="0" i="0" dirty="0">
+                <a:solidFill>
+                  <a:srgbClr val="D0D8E8"/>
+                </a:solidFill>
+              </a:rPr>
+              <a:t>·  Snapshot-</a:t>
+            </a:r>
+            <a:r>
+              <a:rPr sz="1300" b="0" i="0" dirty="0" err="1">
+                <a:solidFill>
+                  <a:srgbClr val="D0D8E8"/>
+                </a:solidFill>
+              </a:rPr>
+              <a:t>systeem</a:t>
+            </a:r>
+            <a:r>
+              <a:rPr sz="1300" b="0" i="0" dirty="0">
+                <a:solidFill>
+                  <a:srgbClr val="D0D8E8"/>
+                </a:solidFill>
+              </a:rPr>
+              <a:t>: </a:t>
+            </a:r>
+            <a:r>
+              <a:rPr sz="1300" b="0" i="0" dirty="0" err="1">
+                <a:solidFill>
+                  <a:srgbClr val="D0D8E8"/>
+                </a:solidFill>
+              </a:rPr>
+              <a:t>wekelijkse</a:t>
+            </a:r>
+            <a:r>
+              <a:rPr sz="1300" b="0" i="0" dirty="0">
+                <a:solidFill>
+                  <a:srgbClr val="D0D8E8"/>
+                </a:solidFill>
+              </a:rPr>
+              <a:t> </a:t>
+            </a:r>
+            <a:r>
+              <a:rPr sz="1300" b="0" i="0" dirty="0" err="1">
+                <a:solidFill>
+                  <a:srgbClr val="D0D8E8"/>
+                </a:solidFill>
+              </a:rPr>
+              <a:t>storingssnapshots</a:t>
+            </a:r>
+            <a:r>
+              <a:rPr sz="1300" b="0" i="0" dirty="0">
+                <a:solidFill>
+                  <a:srgbClr val="D0D8E8"/>
+                </a:solidFill>
+              </a:rPr>
+              <a:t> + backfill-scripts</a:t>
             </a:r>
           </a:p>
           <a:p>
@@ -4103,28 +4689,58 @@
               </a:spcBef>
             </a:pPr>
             <a:r>
-              <a:rPr sz="1300" b="0" i="0">
-                <a:solidFill>
-                  <a:srgbClr val="D0D8E8"/>
-                </a:solidFill>
-              </a:rPr>
-              <a:t>·  MailService: geautomatiseerde e-mailrapporten via SMTP</a:t>
-            </a:r>
-          </a:p>
-          <a:p>
-            <a:pPr algn="l">
-              <a:spcBef>
-                <a:spcPts val="700"/>
-              </a:spcBef>
-            </a:pPr>
-            <a:r>
-              <a:rPr sz="1300" b="0" i="0">
-                <a:solidFill>
-                  <a:srgbClr val="D0D8E8"/>
-                </a:solidFill>
-              </a:rPr>
-              <a:t>·  DB-migratiescripts en validatietooling</a:t>
-            </a:r>
+              <a:rPr sz="1300" b="0" i="0" dirty="0">
+                <a:solidFill>
+                  <a:srgbClr val="D0D8E8"/>
+                </a:solidFill>
+              </a:rPr>
+              <a:t>·  DB-</a:t>
+            </a:r>
+            <a:r>
+              <a:rPr sz="1300" b="0" i="0" dirty="0" err="1">
+                <a:solidFill>
+                  <a:srgbClr val="D0D8E8"/>
+                </a:solidFill>
+              </a:rPr>
+              <a:t>migratiescripts</a:t>
+            </a:r>
+            <a:r>
+              <a:rPr sz="1300" b="0" i="0" dirty="0">
+                <a:solidFill>
+                  <a:srgbClr val="D0D8E8"/>
+                </a:solidFill>
+              </a:rPr>
+              <a:t> </a:t>
+            </a:r>
+            <a:r>
+              <a:rPr sz="1300" b="0" i="0" dirty="0" err="1">
+                <a:solidFill>
+                  <a:srgbClr val="D0D8E8"/>
+                </a:solidFill>
+              </a:rPr>
+              <a:t>en</a:t>
+            </a:r>
+            <a:r>
+              <a:rPr sz="1300" b="0" i="0" dirty="0">
+                <a:solidFill>
+                  <a:srgbClr val="D0D8E8"/>
+                </a:solidFill>
+              </a:rPr>
+              <a:t> </a:t>
+            </a:r>
+            <a:r>
+              <a:rPr sz="1300" b="0" i="0" dirty="0" err="1">
+                <a:solidFill>
+                  <a:srgbClr val="D0D8E8"/>
+                </a:solidFill>
+              </a:rPr>
+              <a:t>validatietooling</a:t>
+            </a:r>
+            <a:endParaRPr sz="1300" b="0" i="0" dirty="0">
+              <a:solidFill>
+                <a:srgbClr val="D0D8E8"/>
+              </a:solidFill>
+            </a:endParaRPr>
           </a:p>
         </p:txBody>
       </p:sp>
@@ -4137,7 +4753,7 @@
 </file>
 
 <file path=ppt/slides/slide11.xml><?xml version="1.0" encoding="utf-8"?>
-<p:sld xmlns:a="http://schemas.openxmlformats.org/drawingml/2006/main" xmlns:p="http://schemas.openxmlformats.org/presentationml/2006/main" xmlns:r="http://schemas.openxmlformats.org/officeDocument/2006/relationships">
+<p:sld xmlns:a="http://schemas.openxmlformats.org/drawingml/2006/main" xmlns:r="http://schemas.openxmlformats.org/officeDocument/2006/relationships" xmlns:p="http://schemas.openxmlformats.org/presentationml/2006/main">
   <p:cSld>
     <p:spTree>
       <p:nvGrpSpPr>
@@ -4145,7 +4761,14 @@
         <p:cNvGrpSpPr/>
         <p:nvPr/>
       </p:nvGrpSpPr>
-      <p:grpSpPr/>
+      <p:grpSpPr>
+        <a:xfrm>
+          <a:off x="0" y="0"/>
+          <a:ext cx="0" cy="0"/>
+          <a:chOff x="0" y="0"/>
+          <a:chExt cx="0" cy="0"/>
+        </a:xfrm>
+      </p:grpSpPr>
       <p:sp>
         <p:nvSpPr>
           <p:cNvPr id="2" name="Rectangle 1"/>
@@ -4186,6 +4809,7 @@
           <a:lstStyle/>
           <a:p>
             <a:pPr algn="ctr"/>
+            <a:endParaRPr/>
           </a:p>
         </p:txBody>
       </p:sp>
@@ -4229,6 +4853,7 @@
           <a:lstStyle/>
           <a:p>
             <a:pPr algn="ctr"/>
+            <a:endParaRPr/>
           </a:p>
         </p:txBody>
       </p:sp>
@@ -4330,6 +4955,7 @@
           <a:lstStyle/>
           <a:p>
             <a:pPr algn="ctr"/>
+            <a:endParaRPr/>
           </a:p>
         </p:txBody>
       </p:sp>
@@ -4373,6 +4999,7 @@
           <a:lstStyle/>
           <a:p>
             <a:pPr algn="ctr"/>
+            <a:endParaRPr/>
           </a:p>
         </p:txBody>
       </p:sp>
@@ -4431,7 +5058,9 @@
             <a:spAutoFit/>
           </a:bodyPr>
           <a:lstStyle/>
-          <a:p/>
+          <a:p>
+            <a:endParaRPr/>
+          </a:p>
           <a:p>
             <a:pPr algn="l">
               <a:spcBef>
@@ -4534,6 +5163,7 @@
           <a:lstStyle/>
           <a:p>
             <a:pPr algn="ctr"/>
+            <a:endParaRPr/>
           </a:p>
         </p:txBody>
       </p:sp>
@@ -4577,6 +5207,7 @@
           <a:lstStyle/>
           <a:p>
             <a:pPr algn="ctr"/>
+            <a:endParaRPr/>
           </a:p>
         </p:txBody>
       </p:sp>
@@ -4635,7 +5266,9 @@
             <a:spAutoFit/>
           </a:bodyPr>
           <a:lstStyle/>
-          <a:p/>
+          <a:p>
+            <a:endParaRPr/>
+          </a:p>
           <a:p>
             <a:pPr algn="l">
               <a:spcBef>
@@ -4738,6 +5371,7 @@
           <a:lstStyle/>
           <a:p>
             <a:pPr algn="ctr"/>
+            <a:endParaRPr/>
           </a:p>
         </p:txBody>
       </p:sp>
@@ -4781,6 +5415,7 @@
           <a:lstStyle/>
           <a:p>
             <a:pPr algn="ctr"/>
+            <a:endParaRPr/>
           </a:p>
         </p:txBody>
       </p:sp>
@@ -4839,7 +5474,9 @@
             <a:spAutoFit/>
           </a:bodyPr>
           <a:lstStyle/>
-          <a:p/>
+          <a:p>
+            <a:endParaRPr/>
+          </a:p>
           <a:p>
             <a:pPr algn="l">
               <a:spcBef>
@@ -4942,6 +5579,7 @@
           <a:lstStyle/>
           <a:p>
             <a:pPr algn="ctr"/>
+            <a:endParaRPr/>
           </a:p>
         </p:txBody>
       </p:sp>
@@ -4985,6 +5623,7 @@
           <a:lstStyle/>
           <a:p>
             <a:pPr algn="ctr"/>
+            <a:endParaRPr/>
           </a:p>
         </p:txBody>
       </p:sp>
@@ -5043,7 +5682,9 @@
             <a:spAutoFit/>
           </a:bodyPr>
           <a:lstStyle/>
-          <a:p/>
+          <a:p>
+            <a:endParaRPr/>
+          </a:p>
           <a:p>
             <a:pPr algn="l">
               <a:spcBef>
@@ -5115,7 +5756,7 @@
 </file>
 
 <file path=ppt/slides/slide12.xml><?xml version="1.0" encoding="utf-8"?>
-<p:sld xmlns:a="http://schemas.openxmlformats.org/drawingml/2006/main" xmlns:p="http://schemas.openxmlformats.org/presentationml/2006/main" xmlns:r="http://schemas.openxmlformats.org/officeDocument/2006/relationships">
+<p:sld xmlns:a="http://schemas.openxmlformats.org/drawingml/2006/main" xmlns:r="http://schemas.openxmlformats.org/officeDocument/2006/relationships" xmlns:p="http://schemas.openxmlformats.org/presentationml/2006/main">
   <p:cSld>
     <p:spTree>
       <p:nvGrpSpPr>
@@ -5123,7 +5764,14 @@
         <p:cNvGrpSpPr/>
         <p:nvPr/>
       </p:nvGrpSpPr>
-      <p:grpSpPr/>
+      <p:grpSpPr>
+        <a:xfrm>
+          <a:off x="0" y="0"/>
+          <a:ext cx="0" cy="0"/>
+          <a:chOff x="0" y="0"/>
+          <a:chExt cx="0" cy="0"/>
+        </a:xfrm>
+      </p:grpSpPr>
       <p:sp>
         <p:nvSpPr>
           <p:cNvPr id="2" name="Rectangle 1"/>
@@ -5164,6 +5812,7 @@
           <a:lstStyle/>
           <a:p>
             <a:pPr algn="ctr"/>
+            <a:endParaRPr/>
           </a:p>
         </p:txBody>
       </p:sp>
@@ -5207,6 +5856,7 @@
           <a:lstStyle/>
           <a:p>
             <a:pPr algn="ctr"/>
+            <a:endParaRPr/>
           </a:p>
         </p:txBody>
       </p:sp>
@@ -5366,6 +6016,7 @@
           <a:lstStyle/>
           <a:p>
             <a:pPr algn="ctr"/>
+            <a:endParaRPr/>
           </a:p>
         </p:txBody>
       </p:sp>
@@ -5390,7 +6041,9 @@
             <a:spAutoFit/>
           </a:bodyPr>
           <a:lstStyle/>
-          <a:p/>
+          <a:p>
+            <a:endParaRPr/>
+          </a:p>
           <a:p>
             <a:pPr>
               <a:spcBef>
@@ -5604,7 +6257,7 @@
 </file>
 
 <file path=ppt/slides/slide13.xml><?xml version="1.0" encoding="utf-8"?>
-<p:sld xmlns:a="http://schemas.openxmlformats.org/drawingml/2006/main" xmlns:p="http://schemas.openxmlformats.org/presentationml/2006/main" xmlns:r="http://schemas.openxmlformats.org/officeDocument/2006/relationships">
+<p:sld xmlns:a="http://schemas.openxmlformats.org/drawingml/2006/main" xmlns:r="http://schemas.openxmlformats.org/officeDocument/2006/relationships" xmlns:p="http://schemas.openxmlformats.org/presentationml/2006/main">
   <p:cSld>
     <p:spTree>
       <p:nvGrpSpPr>
@@ -5612,7 +6265,14 @@
         <p:cNvGrpSpPr/>
         <p:nvPr/>
       </p:nvGrpSpPr>
-      <p:grpSpPr/>
+      <p:grpSpPr>
+        <a:xfrm>
+          <a:off x="0" y="0"/>
+          <a:ext cx="0" cy="0"/>
+          <a:chOff x="0" y="0"/>
+          <a:chExt cx="0" cy="0"/>
+        </a:xfrm>
+      </p:grpSpPr>
       <p:sp>
         <p:nvSpPr>
           <p:cNvPr id="2" name="Rectangle 1"/>
@@ -5653,6 +6313,7 @@
           <a:lstStyle/>
           <a:p>
             <a:pPr algn="ctr"/>
+            <a:endParaRPr/>
           </a:p>
         </p:txBody>
       </p:sp>
@@ -5696,6 +6357,7 @@
           <a:lstStyle/>
           <a:p>
             <a:pPr algn="ctr"/>
+            <a:endParaRPr/>
           </a:p>
         </p:txBody>
       </p:sp>
@@ -5831,6 +6493,7 @@
           <a:lstStyle/>
           <a:p>
             <a:pPr algn="ctr"/>
+            <a:endParaRPr/>
           </a:p>
         </p:txBody>
       </p:sp>
@@ -5874,6 +6537,7 @@
           <a:lstStyle/>
           <a:p>
             <a:pPr algn="ctr"/>
+            <a:endParaRPr/>
           </a:p>
         </p:txBody>
       </p:sp>
@@ -5966,7 +6630,9 @@
             <a:spAutoFit/>
           </a:bodyPr>
           <a:lstStyle/>
-          <a:p/>
+          <a:p>
+            <a:endParaRPr/>
+          </a:p>
           <a:p>
             <a:pPr algn="l">
               <a:spcBef>
@@ -6129,6 +6795,7 @@
           <a:lstStyle/>
           <a:p>
             <a:pPr algn="ctr"/>
+            <a:endParaRPr/>
           </a:p>
         </p:txBody>
       </p:sp>
@@ -6172,6 +6839,7 @@
           <a:lstStyle/>
           <a:p>
             <a:pPr algn="ctr"/>
+            <a:endParaRPr/>
           </a:p>
         </p:txBody>
       </p:sp>
@@ -6264,7 +6932,9 @@
             <a:spAutoFit/>
           </a:bodyPr>
           <a:lstStyle/>
-          <a:p/>
+          <a:p>
+            <a:endParaRPr/>
+          </a:p>
           <a:p>
             <a:pPr algn="l">
               <a:spcBef>
@@ -6382,6 +7052,7 @@
           <a:lstStyle/>
           <a:p>
             <a:pPr algn="ctr"/>
+            <a:endParaRPr/>
           </a:p>
         </p:txBody>
       </p:sp>
@@ -6425,6 +7096,7 @@
           <a:lstStyle/>
           <a:p>
             <a:pPr algn="ctr"/>
+            <a:endParaRPr/>
           </a:p>
         </p:txBody>
       </p:sp>
@@ -6517,7 +7189,9 @@
             <a:spAutoFit/>
           </a:bodyPr>
           <a:lstStyle/>
-          <a:p/>
+          <a:p>
+            <a:endParaRPr/>
+          </a:p>
           <a:p>
             <a:pPr algn="l">
               <a:spcBef>
@@ -6620,6 +7294,7 @@
           <a:lstStyle/>
           <a:p>
             <a:pPr algn="ctr"/>
+            <a:endParaRPr/>
           </a:p>
         </p:txBody>
       </p:sp>
@@ -6663,6 +7338,7 @@
           <a:lstStyle/>
           <a:p>
             <a:pPr algn="ctr"/>
+            <a:endParaRPr/>
           </a:p>
         </p:txBody>
       </p:sp>
@@ -6755,7 +7431,9 @@
             <a:spAutoFit/>
           </a:bodyPr>
           <a:lstStyle/>
-          <a:p/>
+          <a:p>
+            <a:endParaRPr/>
+          </a:p>
           <a:p>
             <a:pPr algn="l">
               <a:spcBef>
@@ -6827,7 +7505,7 @@
 </file>
 
 <file path=ppt/slides/slide14.xml><?xml version="1.0" encoding="utf-8"?>
-<p:sld xmlns:a="http://schemas.openxmlformats.org/drawingml/2006/main" xmlns:p="http://schemas.openxmlformats.org/presentationml/2006/main" xmlns:r="http://schemas.openxmlformats.org/officeDocument/2006/relationships">
+<p:sld xmlns:a="http://schemas.openxmlformats.org/drawingml/2006/main" xmlns:r="http://schemas.openxmlformats.org/officeDocument/2006/relationships" xmlns:p="http://schemas.openxmlformats.org/presentationml/2006/main">
   <p:cSld>
     <p:spTree>
       <p:nvGrpSpPr>
@@ -6835,7 +7513,14 @@
         <p:cNvGrpSpPr/>
         <p:nvPr/>
       </p:nvGrpSpPr>
-      <p:grpSpPr/>
+      <p:grpSpPr>
+        <a:xfrm>
+          <a:off x="0" y="0"/>
+          <a:ext cx="0" cy="0"/>
+          <a:chOff x="0" y="0"/>
+          <a:chExt cx="0" cy="0"/>
+        </a:xfrm>
+      </p:grpSpPr>
       <p:sp>
         <p:nvSpPr>
           <p:cNvPr id="2" name="Rectangle 1"/>
@@ -6876,6 +7561,7 @@
           <a:lstStyle/>
           <a:p>
             <a:pPr algn="ctr"/>
+            <a:endParaRPr/>
           </a:p>
         </p:txBody>
       </p:sp>
@@ -6919,6 +7605,7 @@
           <a:lstStyle/>
           <a:p>
             <a:pPr algn="ctr"/>
+            <a:endParaRPr/>
           </a:p>
         </p:txBody>
       </p:sp>
@@ -7054,6 +7741,7 @@
           <a:lstStyle/>
           <a:p>
             <a:pPr algn="ctr"/>
+            <a:endParaRPr/>
           </a:p>
         </p:txBody>
       </p:sp>
@@ -7131,6 +7819,7 @@
           <a:lstStyle/>
           <a:p>
             <a:pPr algn="ctr"/>
+            <a:endParaRPr/>
           </a:p>
         </p:txBody>
       </p:sp>
@@ -7174,6 +7863,7 @@
           <a:lstStyle/>
           <a:p>
             <a:pPr algn="ctr"/>
+            <a:endParaRPr/>
           </a:p>
         </p:txBody>
       </p:sp>
@@ -7285,6 +7975,7 @@
           <a:lstStyle/>
           <a:p>
             <a:pPr algn="ctr"/>
+            <a:endParaRPr/>
           </a:p>
         </p:txBody>
       </p:sp>
@@ -7362,6 +8053,7 @@
           <a:lstStyle/>
           <a:p>
             <a:pPr algn="ctr"/>
+            <a:endParaRPr/>
           </a:p>
         </p:txBody>
       </p:sp>
@@ -7405,6 +8097,7 @@
           <a:lstStyle/>
           <a:p>
             <a:pPr algn="ctr"/>
+            <a:endParaRPr/>
           </a:p>
         </p:txBody>
       </p:sp>
@@ -7516,6 +8209,7 @@
           <a:lstStyle/>
           <a:p>
             <a:pPr algn="ctr"/>
+            <a:endParaRPr/>
           </a:p>
         </p:txBody>
       </p:sp>
@@ -7593,6 +8287,7 @@
           <a:lstStyle/>
           <a:p>
             <a:pPr algn="ctr"/>
+            <a:endParaRPr/>
           </a:p>
         </p:txBody>
       </p:sp>
@@ -7636,6 +8331,7 @@
           <a:lstStyle/>
           <a:p>
             <a:pPr algn="ctr"/>
+            <a:endParaRPr/>
           </a:p>
         </p:txBody>
       </p:sp>
@@ -7747,6 +8443,7 @@
           <a:lstStyle/>
           <a:p>
             <a:pPr algn="ctr"/>
+            <a:endParaRPr/>
           </a:p>
         </p:txBody>
       </p:sp>
@@ -7824,6 +8521,7 @@
           <a:lstStyle/>
           <a:p>
             <a:pPr algn="ctr"/>
+            <a:endParaRPr/>
           </a:p>
         </p:txBody>
       </p:sp>
@@ -7867,6 +8565,7 @@
           <a:lstStyle/>
           <a:p>
             <a:pPr algn="ctr"/>
+            <a:endParaRPr/>
           </a:p>
         </p:txBody>
       </p:sp>
@@ -7978,6 +8677,7 @@
           <a:lstStyle/>
           <a:p>
             <a:pPr algn="ctr"/>
+            <a:endParaRPr/>
           </a:p>
         </p:txBody>
       </p:sp>
@@ -8055,6 +8755,7 @@
           <a:lstStyle/>
           <a:p>
             <a:pPr algn="ctr"/>
+            <a:endParaRPr/>
           </a:p>
         </p:txBody>
       </p:sp>
@@ -8098,6 +8799,7 @@
           <a:lstStyle/>
           <a:p>
             <a:pPr algn="ctr"/>
+            <a:endParaRPr/>
           </a:p>
         </p:txBody>
       </p:sp>
@@ -8178,7 +8880,7 @@
 </file>
 
 <file path=ppt/slides/slide15.xml><?xml version="1.0" encoding="utf-8"?>
-<p:sld xmlns:a="http://schemas.openxmlformats.org/drawingml/2006/main" xmlns:p="http://schemas.openxmlformats.org/presentationml/2006/main" xmlns:r="http://schemas.openxmlformats.org/officeDocument/2006/relationships">
+<p:sld xmlns:a="http://schemas.openxmlformats.org/drawingml/2006/main" xmlns:r="http://schemas.openxmlformats.org/officeDocument/2006/relationships" xmlns:p="http://schemas.openxmlformats.org/presentationml/2006/main">
   <p:cSld>
     <p:spTree>
       <p:nvGrpSpPr>
@@ -8186,7 +8888,14 @@
         <p:cNvGrpSpPr/>
         <p:nvPr/>
       </p:nvGrpSpPr>
-      <p:grpSpPr/>
+      <p:grpSpPr>
+        <a:xfrm>
+          <a:off x="0" y="0"/>
+          <a:ext cx="0" cy="0"/>
+          <a:chOff x="0" y="0"/>
+          <a:chExt cx="0" cy="0"/>
+        </a:xfrm>
+      </p:grpSpPr>
       <p:sp>
         <p:nvSpPr>
           <p:cNvPr id="2" name="Rectangle 1"/>
@@ -8227,6 +8936,7 @@
           <a:lstStyle/>
           <a:p>
             <a:pPr algn="ctr"/>
+            <a:endParaRPr/>
           </a:p>
         </p:txBody>
       </p:sp>
@@ -8270,6 +8980,7 @@
           <a:lstStyle/>
           <a:p>
             <a:pPr algn="ctr"/>
+            <a:endParaRPr/>
           </a:p>
         </p:txBody>
       </p:sp>
@@ -8405,6 +9116,7 @@
           <a:lstStyle/>
           <a:p>
             <a:pPr algn="ctr"/>
+            <a:endParaRPr/>
           </a:p>
         </p:txBody>
       </p:sp>
@@ -8448,6 +9160,7 @@
           <a:lstStyle/>
           <a:p>
             <a:pPr algn="ctr"/>
+            <a:endParaRPr/>
           </a:p>
         </p:txBody>
       </p:sp>
@@ -8506,7 +9219,9 @@
             <a:spAutoFit/>
           </a:bodyPr>
           <a:lstStyle/>
-          <a:p/>
+          <a:p>
+            <a:endParaRPr/>
+          </a:p>
           <a:p>
             <a:pPr algn="l">
               <a:spcBef>
@@ -8639,6 +9354,7 @@
           <a:lstStyle/>
           <a:p>
             <a:pPr algn="ctr"/>
+            <a:endParaRPr/>
           </a:p>
         </p:txBody>
       </p:sp>
@@ -8682,6 +9398,7 @@
           <a:lstStyle/>
           <a:p>
             <a:pPr algn="ctr"/>
+            <a:endParaRPr/>
           </a:p>
         </p:txBody>
       </p:sp>
@@ -8740,7 +9457,9 @@
             <a:spAutoFit/>
           </a:bodyPr>
           <a:lstStyle/>
-          <a:p/>
+          <a:p>
+            <a:endParaRPr/>
+          </a:p>
           <a:p>
             <a:pPr algn="l">
               <a:spcBef>
@@ -8873,6 +9592,7 @@
           <a:lstStyle/>
           <a:p>
             <a:pPr algn="ctr"/>
+            <a:endParaRPr/>
           </a:p>
         </p:txBody>
       </p:sp>
@@ -8916,6 +9636,7 @@
           <a:lstStyle/>
           <a:p>
             <a:pPr algn="ctr"/>
+            <a:endParaRPr/>
           </a:p>
         </p:txBody>
       </p:sp>
@@ -8996,7 +9717,7 @@
 </file>
 
 <file path=ppt/slides/slide2.xml><?xml version="1.0" encoding="utf-8"?>
-<p:sld xmlns:a="http://schemas.openxmlformats.org/drawingml/2006/main" xmlns:p="http://schemas.openxmlformats.org/presentationml/2006/main" xmlns:r="http://schemas.openxmlformats.org/officeDocument/2006/relationships">
+<p:sld xmlns:a="http://schemas.openxmlformats.org/drawingml/2006/main" xmlns:r="http://schemas.openxmlformats.org/officeDocument/2006/relationships" xmlns:p="http://schemas.openxmlformats.org/presentationml/2006/main">
   <p:cSld>
     <p:spTree>
       <p:nvGrpSpPr>
@@ -9004,7 +9725,14 @@
         <p:cNvGrpSpPr/>
         <p:nvPr/>
       </p:nvGrpSpPr>
-      <p:grpSpPr/>
+      <p:grpSpPr>
+        <a:xfrm>
+          <a:off x="0" y="0"/>
+          <a:ext cx="0" cy="0"/>
+          <a:chOff x="0" y="0"/>
+          <a:chExt cx="0" cy="0"/>
+        </a:xfrm>
+      </p:grpSpPr>
       <p:sp>
         <p:nvSpPr>
           <p:cNvPr id="2" name="Rectangle 1"/>
@@ -9045,6 +9773,7 @@
           <a:lstStyle/>
           <a:p>
             <a:pPr algn="ctr"/>
+            <a:endParaRPr/>
           </a:p>
         </p:txBody>
       </p:sp>
@@ -9088,6 +9817,7 @@
           <a:lstStyle/>
           <a:p>
             <a:pPr algn="ctr"/>
+            <a:endParaRPr/>
           </a:p>
         </p:txBody>
       </p:sp>
@@ -9204,7 +9934,9 @@
             <a:spAutoFit/>
           </a:bodyPr>
           <a:lstStyle/>
-          <a:p/>
+          <a:p>
+            <a:endParaRPr/>
+          </a:p>
           <a:p>
             <a:pPr>
               <a:spcBef>
@@ -9400,7 +10132,7 @@
 </file>
 
 <file path=ppt/slides/slide3.xml><?xml version="1.0" encoding="utf-8"?>
-<p:sld xmlns:a="http://schemas.openxmlformats.org/drawingml/2006/main" xmlns:p="http://schemas.openxmlformats.org/presentationml/2006/main" xmlns:r="http://schemas.openxmlformats.org/officeDocument/2006/relationships">
+<p:sld xmlns:a="http://schemas.openxmlformats.org/drawingml/2006/main" xmlns:r="http://schemas.openxmlformats.org/officeDocument/2006/relationships" xmlns:p="http://schemas.openxmlformats.org/presentationml/2006/main">
   <p:cSld>
     <p:spTree>
       <p:nvGrpSpPr>
@@ -9408,7 +10140,14 @@
         <p:cNvGrpSpPr/>
         <p:nvPr/>
       </p:nvGrpSpPr>
-      <p:grpSpPr/>
+      <p:grpSpPr>
+        <a:xfrm>
+          <a:off x="0" y="0"/>
+          <a:ext cx="0" cy="0"/>
+          <a:chOff x="0" y="0"/>
+          <a:chExt cx="0" cy="0"/>
+        </a:xfrm>
+      </p:grpSpPr>
       <p:sp>
         <p:nvSpPr>
           <p:cNvPr id="2" name="Rectangle 1"/>
@@ -9449,6 +10188,7 @@
           <a:lstStyle/>
           <a:p>
             <a:pPr algn="ctr"/>
+            <a:endParaRPr/>
           </a:p>
         </p:txBody>
       </p:sp>
@@ -9492,6 +10232,7 @@
           <a:lstStyle/>
           <a:p>
             <a:pPr algn="ctr"/>
+            <a:endParaRPr/>
           </a:p>
         </p:txBody>
       </p:sp>
@@ -9627,6 +10368,7 @@
           <a:lstStyle/>
           <a:p>
             <a:pPr algn="ctr"/>
+            <a:endParaRPr/>
           </a:p>
         </p:txBody>
       </p:sp>
@@ -9670,6 +10412,7 @@
           <a:lstStyle/>
           <a:p>
             <a:pPr algn="ctr"/>
+            <a:endParaRPr/>
           </a:p>
         </p:txBody>
       </p:sp>
@@ -9713,6 +10456,7 @@
           <a:lstStyle/>
           <a:p>
             <a:pPr algn="ctr"/>
+            <a:endParaRPr/>
           </a:p>
         </p:txBody>
       </p:sp>
@@ -9771,7 +10515,9 @@
             <a:spAutoFit/>
           </a:bodyPr>
           <a:lstStyle/>
-          <a:p/>
+          <a:p>
+            <a:endParaRPr dirty="0"/>
+          </a:p>
           <a:p>
             <a:pPr algn="l">
               <a:spcBef>
@@ -9779,13 +10525,90 @@
               </a:spcBef>
             </a:pPr>
             <a:r>
-              <a:rPr sz="1400" b="0" i="0">
-                <a:solidFill>
-                  <a:srgbClr val="D0D8E8"/>
-                </a:solidFill>
-              </a:rPr>
-              <a:t>›  CIMPLICITY logt duizenden alarmen per dag op de ArcelorMittal-productielijn</a:t>
-            </a:r>
+              <a:rPr sz="1400" b="0" i="0" dirty="0">
+                <a:solidFill>
+                  <a:srgbClr val="D0D8E8"/>
+                </a:solidFill>
+              </a:rPr>
+              <a:t>›  CIMPLICITY </a:t>
+            </a:r>
+            <a:r>
+              <a:rPr sz="1400" b="0" i="0" dirty="0" err="1">
+                <a:solidFill>
+                  <a:srgbClr val="D0D8E8"/>
+                </a:solidFill>
+              </a:rPr>
+              <a:t>logt</a:t>
+            </a:r>
+            <a:r>
+              <a:rPr sz="1400" b="0" i="0" dirty="0">
+                <a:solidFill>
+                  <a:srgbClr val="D0D8E8"/>
+                </a:solidFill>
+              </a:rPr>
+              <a:t> </a:t>
+            </a:r>
+            <a:r>
+              <a:rPr sz="1400" b="0" i="0" dirty="0" err="1">
+                <a:solidFill>
+                  <a:srgbClr val="D0D8E8"/>
+                </a:solidFill>
+              </a:rPr>
+              <a:t>duizenden</a:t>
+            </a:r>
+            <a:r>
+              <a:rPr sz="1400" b="0" i="0" dirty="0">
+                <a:solidFill>
+                  <a:srgbClr val="D0D8E8"/>
+                </a:solidFill>
+              </a:rPr>
+              <a:t> </a:t>
+            </a:r>
+            <a:r>
+              <a:rPr sz="1400" b="0" i="0" dirty="0" err="1">
+                <a:solidFill>
+                  <a:srgbClr val="D0D8E8"/>
+                </a:solidFill>
+              </a:rPr>
+              <a:t>alarmen</a:t>
+            </a:r>
+            <a:r>
+              <a:rPr sz="1400" b="0" i="0" dirty="0">
+                <a:solidFill>
+                  <a:srgbClr val="D0D8E8"/>
+                </a:solidFill>
+              </a:rPr>
+              <a:t> per </a:t>
+            </a:r>
+            <a:r>
+              <a:rPr sz="1400" b="0" i="0" dirty="0" err="1">
+                <a:solidFill>
+                  <a:srgbClr val="D0D8E8"/>
+                </a:solidFill>
+              </a:rPr>
+              <a:t>dag</a:t>
+            </a:r>
+            <a:r>
+              <a:rPr sz="1400" b="0" i="0" dirty="0">
+                <a:solidFill>
+                  <a:srgbClr val="D0D8E8"/>
+                </a:solidFill>
+              </a:rPr>
+              <a:t> op de ArcelorMittal-</a:t>
+            </a:r>
+            <a:r>
+              <a:rPr sz="1400" b="0" i="0" dirty="0" err="1">
+                <a:solidFill>
+                  <a:srgbClr val="D0D8E8"/>
+                </a:solidFill>
+              </a:rPr>
+              <a:t>productielijn</a:t>
+            </a:r>
+            <a:endParaRPr sz="1400" b="0" i="0" dirty="0">
+              <a:solidFill>
+                <a:srgbClr val="D0D8E8"/>
+              </a:solidFill>
+            </a:endParaRPr>
           </a:p>
           <a:p>
             <a:pPr algn="l">
@@ -9794,13 +10617,122 @@
               </a:spcBef>
             </a:pPr>
             <a:r>
-              <a:rPr sz="1400" b="0" i="0">
-                <a:solidFill>
-                  <a:srgbClr val="D0D8E8"/>
-                </a:solidFill>
-              </a:rPr>
-              <a:t>›  Bestaande tools tonen enkel real-time alarmen — geen historische analyse</a:t>
-            </a:r>
+              <a:rPr sz="1400" b="0" i="0" dirty="0">
+                <a:solidFill>
+                  <a:srgbClr val="D0D8E8"/>
+                </a:solidFill>
+              </a:rPr>
+              <a:t>›  </a:t>
+            </a:r>
+            <a:r>
+              <a:rPr sz="1400" b="0" i="0" dirty="0" err="1">
+                <a:solidFill>
+                  <a:srgbClr val="D0D8E8"/>
+                </a:solidFill>
+              </a:rPr>
+              <a:t>Bestaande</a:t>
+            </a:r>
+            <a:r>
+              <a:rPr sz="1400" b="0" i="0" dirty="0">
+                <a:solidFill>
+                  <a:srgbClr val="D0D8E8"/>
+                </a:solidFill>
+              </a:rPr>
+              <a:t> tools </a:t>
+            </a:r>
+            <a:r>
+              <a:rPr sz="1400" b="0" i="0" dirty="0" err="1">
+                <a:solidFill>
+                  <a:srgbClr val="D0D8E8"/>
+                </a:solidFill>
+              </a:rPr>
+              <a:t>tonen</a:t>
+            </a:r>
+            <a:r>
+              <a:rPr sz="1400" b="0" i="0" dirty="0">
+                <a:solidFill>
+                  <a:srgbClr val="D0D8E8"/>
+                </a:solidFill>
+              </a:rPr>
+              <a:t> </a:t>
+            </a:r>
+            <a:r>
+              <a:rPr sz="1400" b="0" i="0" dirty="0" err="1">
+                <a:solidFill>
+                  <a:srgbClr val="D0D8E8"/>
+                </a:solidFill>
+              </a:rPr>
+              <a:t>enkel</a:t>
+            </a:r>
+            <a:r>
+              <a:rPr sz="1400" b="0" i="0" dirty="0">
+                <a:solidFill>
+                  <a:srgbClr val="D0D8E8"/>
+                </a:solidFill>
+              </a:rPr>
+              <a:t> real-time </a:t>
+            </a:r>
+            <a:r>
+              <a:rPr sz="1400" b="0" i="0" dirty="0" err="1">
+                <a:solidFill>
+                  <a:srgbClr val="D0D8E8"/>
+                </a:solidFill>
+              </a:rPr>
+              <a:t>alarmen</a:t>
+            </a:r>
+            <a:r>
+              <a:rPr sz="1400" b="0" i="0" dirty="0">
+                <a:solidFill>
+                  <a:srgbClr val="D0D8E8"/>
+                </a:solidFill>
+              </a:rPr>
+              <a:t> — </a:t>
+            </a:r>
+            <a:r>
+              <a:rPr sz="1400" b="0" i="0" dirty="0" err="1">
+                <a:solidFill>
+                  <a:srgbClr val="D0D8E8"/>
+                </a:solidFill>
+              </a:rPr>
+              <a:t>geen</a:t>
+            </a:r>
+            <a:r>
+              <a:rPr sz="1400" b="0" i="0" dirty="0">
+                <a:solidFill>
+                  <a:srgbClr val="D0D8E8"/>
+                </a:solidFill>
+              </a:rPr>
+              <a:t> </a:t>
+            </a:r>
+            <a:r>
+              <a:rPr sz="1400" b="0" i="0" dirty="0" err="1">
+                <a:solidFill>
+                  <a:srgbClr val="D0D8E8"/>
+                </a:solidFill>
+              </a:rPr>
+              <a:t>historische</a:t>
+            </a:r>
+            <a:r>
+              <a:rPr sz="1400" b="0" i="0" dirty="0">
+                <a:solidFill>
+                  <a:srgbClr val="D0D8E8"/>
+                </a:solidFill>
+              </a:rPr>
+              <a:t> </a:t>
+            </a:r>
+            <a:r>
+              <a:rPr sz="1400" b="0" i="0" dirty="0" err="1">
+                <a:solidFill>
+                  <a:srgbClr val="D0D8E8"/>
+                </a:solidFill>
+              </a:rPr>
+              <a:t>analyse</a:t>
+            </a:r>
+            <a:endParaRPr sz="1400" b="0" i="0" dirty="0">
+              <a:solidFill>
+                <a:srgbClr val="D0D8E8"/>
+              </a:solidFill>
+            </a:endParaRPr>
           </a:p>
           <a:p>
             <a:pPr algn="l">
@@ -9809,13 +10741,122 @@
               </a:spcBef>
             </a:pPr>
             <a:r>
-              <a:rPr sz="1400" b="0" i="0">
-                <a:solidFill>
-                  <a:srgbClr val="D0D8E8"/>
-                </a:solidFill>
-              </a:rPr>
-              <a:t>›  Technici zien niet eenvoudig welke storingen toenemen</a:t>
-            </a:r>
+              <a:rPr sz="1400" b="0" i="0" dirty="0">
+                <a:solidFill>
+                  <a:srgbClr val="D0D8E8"/>
+                </a:solidFill>
+              </a:rPr>
+              <a:t>›  </a:t>
+            </a:r>
+            <a:r>
+              <a:rPr sz="1400" b="0" i="0" dirty="0" err="1">
+                <a:solidFill>
+                  <a:srgbClr val="D0D8E8"/>
+                </a:solidFill>
+              </a:rPr>
+              <a:t>Technici</a:t>
+            </a:r>
+            <a:r>
+              <a:rPr sz="1400" b="0" i="0" dirty="0">
+                <a:solidFill>
+                  <a:srgbClr val="D0D8E8"/>
+                </a:solidFill>
+              </a:rPr>
+              <a:t> </a:t>
+            </a:r>
+            <a:r>
+              <a:rPr sz="1400" b="0" i="0" dirty="0" err="1">
+                <a:solidFill>
+                  <a:srgbClr val="D0D8E8"/>
+                </a:solidFill>
+              </a:rPr>
+              <a:t>zien</a:t>
+            </a:r>
+            <a:r>
+              <a:rPr sz="1400" b="0" i="0" dirty="0">
+                <a:solidFill>
+                  <a:srgbClr val="D0D8E8"/>
+                </a:solidFill>
+              </a:rPr>
+              <a:t> </a:t>
+            </a:r>
+            <a:r>
+              <a:rPr sz="1400" b="0" i="0" dirty="0" err="1">
+                <a:solidFill>
+                  <a:srgbClr val="D0D8E8"/>
+                </a:solidFill>
+              </a:rPr>
+              <a:t>niet</a:t>
+            </a:r>
+            <a:r>
+              <a:rPr sz="1400" b="0" i="0" dirty="0">
+                <a:solidFill>
+                  <a:srgbClr val="D0D8E8"/>
+                </a:solidFill>
+              </a:rPr>
+              <a:t> </a:t>
+            </a:r>
+            <a:r>
+              <a:rPr sz="1400" b="0" i="0" dirty="0" err="1">
+                <a:solidFill>
+                  <a:srgbClr val="D0D8E8"/>
+                </a:solidFill>
+              </a:rPr>
+              <a:t>eenvoudig</a:t>
+            </a:r>
+            <a:r>
+              <a:rPr sz="1400" b="0" i="0" dirty="0">
+                <a:solidFill>
+                  <a:srgbClr val="D0D8E8"/>
+                </a:solidFill>
+              </a:rPr>
+              <a:t> </a:t>
+            </a:r>
+            <a:r>
+              <a:rPr sz="1400" b="0" i="0" dirty="0" err="1">
+                <a:solidFill>
+                  <a:srgbClr val="D0D8E8"/>
+                </a:solidFill>
+              </a:rPr>
+              <a:t>welke</a:t>
+            </a:r>
+            <a:r>
+              <a:rPr sz="1400" b="0" i="0" dirty="0">
+                <a:solidFill>
+                  <a:srgbClr val="D0D8E8"/>
+                </a:solidFill>
+              </a:rPr>
+              <a:t> </a:t>
+            </a:r>
+            <a:r>
+              <a:rPr sz="1400" b="0" i="0" dirty="0" err="1">
+                <a:solidFill>
+                  <a:srgbClr val="D0D8E8"/>
+                </a:solidFill>
+              </a:rPr>
+              <a:t>storingen</a:t>
+            </a:r>
+            <a:r>
+              <a:rPr sz="1400" b="0" i="0" dirty="0">
+                <a:solidFill>
+                  <a:srgbClr val="D0D8E8"/>
+                </a:solidFill>
+              </a:rPr>
+              <a:t> </a:t>
+            </a:r>
+            <a:r>
+              <a:rPr sz="1400" b="0" i="0" dirty="0" err="1">
+                <a:solidFill>
+                  <a:srgbClr val="D0D8E8"/>
+                </a:solidFill>
+              </a:rPr>
+              <a:t>toenemen</a:t>
+            </a:r>
+            <a:endParaRPr sz="1400" b="0" i="0" dirty="0">
+              <a:solidFill>
+                <a:srgbClr val="D0D8E8"/>
+              </a:solidFill>
+            </a:endParaRPr>
           </a:p>
           <a:p>
             <a:pPr algn="l">
@@ -9824,13 +10865,106 @@
               </a:spcBef>
             </a:pPr>
             <a:r>
-              <a:rPr sz="1400" b="0" i="0">
-                <a:solidFill>
-                  <a:srgbClr val="D0D8E8"/>
-                </a:solidFill>
-              </a:rPr>
-              <a:t>›  De grondoorzaak van interlock-ketens zoeken is manueel en tijdrovend</a:t>
-            </a:r>
+              <a:rPr sz="1400" b="0" i="0" dirty="0">
+                <a:solidFill>
+                  <a:srgbClr val="D0D8E8"/>
+                </a:solidFill>
+              </a:rPr>
+              <a:t>›  De </a:t>
+            </a:r>
+            <a:r>
+              <a:rPr sz="1400" b="0" i="0" dirty="0" err="1">
+                <a:solidFill>
+                  <a:srgbClr val="D0D8E8"/>
+                </a:solidFill>
+              </a:rPr>
+              <a:t>grondoorzaak</a:t>
+            </a:r>
+            <a:r>
+              <a:rPr sz="1400" b="0" i="0" dirty="0">
+                <a:solidFill>
+                  <a:srgbClr val="D0D8E8"/>
+                </a:solidFill>
+              </a:rPr>
+              <a:t> van interlock-</a:t>
+            </a:r>
+            <a:r>
+              <a:rPr sz="1400" b="0" i="0" dirty="0" err="1">
+                <a:solidFill>
+                  <a:srgbClr val="D0D8E8"/>
+                </a:solidFill>
+              </a:rPr>
+              <a:t>ketens</a:t>
+            </a:r>
+            <a:r>
+              <a:rPr sz="1400" b="0" i="0" dirty="0">
+                <a:solidFill>
+                  <a:srgbClr val="D0D8E8"/>
+                </a:solidFill>
+              </a:rPr>
+              <a:t> </a:t>
+            </a:r>
+            <a:r>
+              <a:rPr sz="1400" b="0" i="0" dirty="0" err="1">
+                <a:solidFill>
+                  <a:srgbClr val="D0D8E8"/>
+                </a:solidFill>
+              </a:rPr>
+              <a:t>zoeken</a:t>
+            </a:r>
+            <a:r>
+              <a:rPr sz="1400" b="0" i="0" dirty="0">
+                <a:solidFill>
+                  <a:srgbClr val="D0D8E8"/>
+                </a:solidFill>
+              </a:rPr>
+              <a:t> is </a:t>
+            </a:r>
+            <a:r>
+              <a:rPr sz="1400" b="0" i="0" dirty="0" err="1">
+                <a:solidFill>
+                  <a:srgbClr val="D0D8E8"/>
+                </a:solidFill>
+              </a:rPr>
+              <a:t>manueel</a:t>
+            </a:r>
+            <a:r>
+              <a:rPr sz="1400" b="0" i="0" dirty="0">
+                <a:solidFill>
+                  <a:srgbClr val="D0D8E8"/>
+                </a:solidFill>
+              </a:rPr>
+              <a:t> </a:t>
+            </a:r>
+            <a:r>
+              <a:rPr sz="1400" b="0" i="0" dirty="0" err="1">
+                <a:solidFill>
+                  <a:srgbClr val="D0D8E8"/>
+                </a:solidFill>
+              </a:rPr>
+              <a:t>en</a:t>
+            </a:r>
+            <a:r>
+              <a:rPr sz="1400" b="0" i="0" dirty="0">
+                <a:solidFill>
+                  <a:srgbClr val="D0D8E8"/>
+                </a:solidFill>
+              </a:rPr>
+              <a:t> </a:t>
+            </a:r>
+            <a:r>
+              <a:rPr sz="1400" b="0" i="0" dirty="0" err="1">
+                <a:solidFill>
+                  <a:srgbClr val="D0D8E8"/>
+                </a:solidFill>
+              </a:rPr>
+              <a:t>tijdrovend</a:t>
+            </a:r>
+            <a:endParaRPr sz="1400" b="0" i="0" dirty="0">
+              <a:solidFill>
+                <a:srgbClr val="D0D8E8"/>
+              </a:solidFill>
+            </a:endParaRPr>
           </a:p>
           <a:p>
             <a:pPr algn="l">
@@ -9839,13 +10973,74 @@
               </a:spcBef>
             </a:pPr>
             <a:r>
-              <a:rPr sz="1400" b="0" i="0">
-                <a:solidFill>
-                  <a:srgbClr val="D0D8E8"/>
-                </a:solidFill>
-              </a:rPr>
-              <a:t>›  Geen geautomatiseerde rapportering of PDF-export voor ploegoverdracht</a:t>
-            </a:r>
+              <a:rPr sz="1400" b="0" i="0" dirty="0">
+                <a:solidFill>
+                  <a:srgbClr val="D0D8E8"/>
+                </a:solidFill>
+              </a:rPr>
+              <a:t>›  Geen </a:t>
+            </a:r>
+            <a:r>
+              <a:rPr sz="1400" b="0" i="0" dirty="0" err="1">
+                <a:solidFill>
+                  <a:srgbClr val="D0D8E8"/>
+                </a:solidFill>
+              </a:rPr>
+              <a:t>geautomatiseerde</a:t>
+            </a:r>
+            <a:r>
+              <a:rPr sz="1400" b="0" i="0" dirty="0">
+                <a:solidFill>
+                  <a:srgbClr val="D0D8E8"/>
+                </a:solidFill>
+              </a:rPr>
+              <a:t> </a:t>
+            </a:r>
+            <a:r>
+              <a:rPr sz="1400" b="0" i="0" dirty="0" err="1">
+                <a:solidFill>
+                  <a:srgbClr val="D0D8E8"/>
+                </a:solidFill>
+              </a:rPr>
+              <a:t>rapportering</a:t>
+            </a:r>
+            <a:r>
+              <a:rPr sz="1400" b="0" i="0" dirty="0">
+                <a:solidFill>
+                  <a:srgbClr val="D0D8E8"/>
+                </a:solidFill>
+              </a:rPr>
+              <a:t> of PDF-export </a:t>
+            </a:r>
+            <a:r>
+              <a:rPr sz="1400" b="0" i="0" dirty="0" err="1">
+                <a:solidFill>
+                  <a:srgbClr val="D0D8E8"/>
+                </a:solidFill>
+              </a:rPr>
+              <a:t>voor</a:t>
+            </a:r>
+            <a:r>
+              <a:rPr sz="1400" b="0" i="0" dirty="0">
+                <a:solidFill>
+                  <a:srgbClr val="D0D8E8"/>
+                </a:solidFill>
+              </a:rPr>
+              <a:t> </a:t>
+            </a:r>
+            <a:r>
+              <a:rPr sz="1400" b="0" i="0" dirty="0" err="1">
+                <a:solidFill>
+                  <a:srgbClr val="D0D8E8"/>
+                </a:solidFill>
+              </a:rPr>
+              <a:t>ploegoverdracht</a:t>
+            </a:r>
+            <a:endParaRPr sz="1400" b="0" i="0" dirty="0">
+              <a:solidFill>
+                <a:srgbClr val="D0D8E8"/>
+              </a:solidFill>
+            </a:endParaRPr>
           </a:p>
         </p:txBody>
       </p:sp>
@@ -9889,6 +11084,7 @@
           <a:lstStyle/>
           <a:p>
             <a:pPr algn="ctr"/>
+            <a:endParaRPr/>
           </a:p>
         </p:txBody>
       </p:sp>
@@ -9947,7 +11143,9 @@
             <a:spAutoFit/>
           </a:bodyPr>
           <a:lstStyle/>
-          <a:p/>
+          <a:p>
+            <a:endParaRPr dirty="0"/>
+          </a:p>
           <a:p>
             <a:pPr algn="l">
               <a:spcBef>
@@ -9955,13 +11153,58 @@
               </a:spcBef>
             </a:pPr>
             <a:r>
-              <a:rPr sz="1400" b="0" i="0">
-                <a:solidFill>
-                  <a:srgbClr val="D0D8E8"/>
-                </a:solidFill>
-              </a:rPr>
-              <a:t>›  Python/Flask-webapp via IIS — geen nieuwe login nodig</a:t>
-            </a:r>
+              <a:rPr sz="1400" b="0" i="0" dirty="0">
+                <a:solidFill>
+                  <a:srgbClr val="D0D8E8"/>
+                </a:solidFill>
+              </a:rPr>
+              <a:t>›  Python/Flask-webapp via IIS — </a:t>
+            </a:r>
+            <a:r>
+              <a:rPr sz="1400" b="0" i="0" dirty="0" err="1">
+                <a:solidFill>
+                  <a:srgbClr val="D0D8E8"/>
+                </a:solidFill>
+              </a:rPr>
+              <a:t>geen</a:t>
+            </a:r>
+            <a:r>
+              <a:rPr sz="1400" b="0" i="0" dirty="0">
+                <a:solidFill>
+                  <a:srgbClr val="D0D8E8"/>
+                </a:solidFill>
+              </a:rPr>
+              <a:t> </a:t>
+            </a:r>
+            <a:r>
+              <a:rPr sz="1400" b="0" i="0" dirty="0" err="1">
+                <a:solidFill>
+                  <a:srgbClr val="D0D8E8"/>
+                </a:solidFill>
+              </a:rPr>
+              <a:t>nieuwe</a:t>
+            </a:r>
+            <a:r>
+              <a:rPr sz="1400" b="0" i="0" dirty="0">
+                <a:solidFill>
+                  <a:srgbClr val="D0D8E8"/>
+                </a:solidFill>
+              </a:rPr>
+              <a:t> login </a:t>
+            </a:r>
+            <a:r>
+              <a:rPr sz="1400" b="0" i="0" dirty="0" err="1">
+                <a:solidFill>
+                  <a:srgbClr val="D0D8E8"/>
+                </a:solidFill>
+              </a:rPr>
+              <a:t>nodig</a:t>
+            </a:r>
+            <a:endParaRPr sz="1400" b="0" i="0" dirty="0">
+              <a:solidFill>
+                <a:srgbClr val="D0D8E8"/>
+              </a:solidFill>
+            </a:endParaRPr>
           </a:p>
           <a:p>
             <a:pPr algn="l">
@@ -9970,12 +11213,76 @@
               </a:spcBef>
             </a:pPr>
             <a:r>
-              <a:rPr sz="1400" b="0" i="0">
-                <a:solidFill>
-                  <a:srgbClr val="D0D8E8"/>
-                </a:solidFill>
-              </a:rPr>
-              <a:t>›  Interactief dashboard: 6 grafieken + heatmap uit historische SQL Server-data</a:t>
+              <a:rPr sz="1400" b="0" i="0" dirty="0">
+                <a:solidFill>
+                  <a:srgbClr val="D0D8E8"/>
+                </a:solidFill>
+              </a:rPr>
+              <a:t>›  </a:t>
+            </a:r>
+            <a:r>
+              <a:rPr sz="1400" b="0" i="0" dirty="0" err="1">
+                <a:solidFill>
+                  <a:srgbClr val="D0D8E8"/>
+                </a:solidFill>
+              </a:rPr>
+              <a:t>Interactief</a:t>
+            </a:r>
+            <a:r>
+              <a:rPr sz="1400" b="0" i="0" dirty="0">
+                <a:solidFill>
+                  <a:srgbClr val="D0D8E8"/>
+                </a:solidFill>
+              </a:rPr>
+              <a:t> dashboard: 6 </a:t>
+            </a:r>
+            <a:r>
+              <a:rPr sz="1400" b="0" i="0" dirty="0" err="1">
+                <a:solidFill>
+                  <a:srgbClr val="D0D8E8"/>
+                </a:solidFill>
+              </a:rPr>
+              <a:t>grafieken</a:t>
+            </a:r>
+            <a:r>
+              <a:rPr sz="1400" b="0" i="0" dirty="0">
+                <a:solidFill>
+                  <a:srgbClr val="D0D8E8"/>
+                </a:solidFill>
+              </a:rPr>
+              <a:t> + heatmap </a:t>
+            </a:r>
+            <a:r>
+              <a:rPr sz="1400" b="0" i="0" dirty="0" err="1">
+                <a:solidFill>
+                  <a:srgbClr val="D0D8E8"/>
+                </a:solidFill>
+              </a:rPr>
+              <a:t>uit</a:t>
+            </a:r>
+            <a:r>
+              <a:rPr sz="1400" b="0" i="0" dirty="0">
+                <a:solidFill>
+                  <a:srgbClr val="D0D8E8"/>
+                </a:solidFill>
+              </a:rPr>
+              <a:t> </a:t>
+            </a:r>
+            <a:r>
+              <a:rPr sz="1400" b="0" i="0" dirty="0" err="1">
+                <a:solidFill>
+                  <a:srgbClr val="D0D8E8"/>
+                </a:solidFill>
+              </a:rPr>
+              <a:t>historische</a:t>
+            </a:r>
+            <a:r>
+              <a:rPr sz="1400" b="0" i="0" dirty="0">
+                <a:solidFill>
+                  <a:srgbClr val="D0D8E8"/>
+                </a:solidFill>
+              </a:rPr>
+              <a:t> SQL Server-data</a:t>
             </a:r>
           </a:p>
           <a:p>
@@ -9985,13 +11292,90 @@
               </a:spcBef>
             </a:pPr>
             <a:r>
-              <a:rPr sz="1400" b="0" i="0">
-                <a:solidFill>
-                  <a:srgbClr val="D0D8E8"/>
-                </a:solidFill>
-              </a:rPr>
-              <a:t>›  Recursieve interlock-ketentracer: vind de grondfout in seconden</a:t>
-            </a:r>
+              <a:rPr sz="1400" b="0" i="0" dirty="0">
+                <a:solidFill>
+                  <a:srgbClr val="D0D8E8"/>
+                </a:solidFill>
+              </a:rPr>
+              <a:t>›  </a:t>
+            </a:r>
+            <a:r>
+              <a:rPr sz="1400" b="0" i="0" dirty="0" err="1">
+                <a:solidFill>
+                  <a:srgbClr val="D0D8E8"/>
+                </a:solidFill>
+              </a:rPr>
+              <a:t>Recursieve</a:t>
+            </a:r>
+            <a:r>
+              <a:rPr sz="1400" b="0" i="0" dirty="0">
+                <a:solidFill>
+                  <a:srgbClr val="D0D8E8"/>
+                </a:solidFill>
+              </a:rPr>
+              <a:t> interlock-</a:t>
+            </a:r>
+            <a:r>
+              <a:rPr sz="1400" b="0" i="0" dirty="0" err="1">
+                <a:solidFill>
+                  <a:srgbClr val="D0D8E8"/>
+                </a:solidFill>
+              </a:rPr>
+              <a:t>ketentracer</a:t>
+            </a:r>
+            <a:r>
+              <a:rPr sz="1400" b="0" i="0" dirty="0">
+                <a:solidFill>
+                  <a:srgbClr val="D0D8E8"/>
+                </a:solidFill>
+              </a:rPr>
+              <a:t>: </a:t>
+            </a:r>
+            <a:r>
+              <a:rPr sz="1400" b="0" i="0" dirty="0" err="1">
+                <a:solidFill>
+                  <a:srgbClr val="D0D8E8"/>
+                </a:solidFill>
+              </a:rPr>
+              <a:t>vind</a:t>
+            </a:r>
+            <a:r>
+              <a:rPr sz="1400" b="0" i="0" dirty="0">
+                <a:solidFill>
+                  <a:srgbClr val="D0D8E8"/>
+                </a:solidFill>
+              </a:rPr>
+              <a:t> de </a:t>
+            </a:r>
+            <a:r>
+              <a:rPr sz="1400" b="0" i="0" dirty="0" err="1">
+                <a:solidFill>
+                  <a:srgbClr val="D0D8E8"/>
+                </a:solidFill>
+              </a:rPr>
+              <a:t>grondfout</a:t>
+            </a:r>
+            <a:r>
+              <a:rPr sz="1400" b="0" i="0" dirty="0">
+                <a:solidFill>
+                  <a:srgbClr val="D0D8E8"/>
+                </a:solidFill>
+              </a:rPr>
+              <a:t> in </a:t>
+            </a:r>
+            <a:r>
+              <a:rPr sz="1400" b="0" i="0" dirty="0" err="1">
+                <a:solidFill>
+                  <a:srgbClr val="D0D8E8"/>
+                </a:solidFill>
+              </a:rPr>
+              <a:t>seconden</a:t>
+            </a:r>
+            <a:endParaRPr sz="1400" b="0" i="0" dirty="0">
+              <a:solidFill>
+                <a:srgbClr val="D0D8E8"/>
+              </a:solidFill>
+            </a:endParaRPr>
           </a:p>
           <a:p>
             <a:pPr algn="l">
@@ -10000,13 +11384,90 @@
               </a:spcBef>
             </a:pPr>
             <a:r>
-              <a:rPr sz="1400" b="0" i="0">
-                <a:solidFill>
-                  <a:srgbClr val="D0D8E8"/>
-                </a:solidFill>
-              </a:rPr>
-              <a:t>›  Wekelijkse storingssnapshots voor langetermijntrend- &amp; regressiedetectie</a:t>
-            </a:r>
+              <a:rPr sz="1400" b="0" i="0" dirty="0">
+                <a:solidFill>
+                  <a:srgbClr val="D0D8E8"/>
+                </a:solidFill>
+              </a:rPr>
+              <a:t>›  </a:t>
+            </a:r>
+            <a:r>
+              <a:rPr sz="1400" b="0" i="0" dirty="0" err="1">
+                <a:solidFill>
+                  <a:srgbClr val="D0D8E8"/>
+                </a:solidFill>
+              </a:rPr>
+              <a:t>Wekelijkse</a:t>
+            </a:r>
+            <a:r>
+              <a:rPr sz="1400" b="0" i="0" dirty="0">
+                <a:solidFill>
+                  <a:srgbClr val="D0D8E8"/>
+                </a:solidFill>
+              </a:rPr>
+              <a:t> </a:t>
+            </a:r>
+            <a:r>
+              <a:rPr sz="1400" b="0" i="0" dirty="0" err="1">
+                <a:solidFill>
+                  <a:srgbClr val="D0D8E8"/>
+                </a:solidFill>
+              </a:rPr>
+              <a:t>storingssnapshots</a:t>
+            </a:r>
+            <a:r>
+              <a:rPr sz="1400" b="0" i="0" dirty="0">
+                <a:solidFill>
+                  <a:srgbClr val="D0D8E8"/>
+                </a:solidFill>
+              </a:rPr>
+              <a:t> </a:t>
+            </a:r>
+            <a:r>
+              <a:rPr sz="1400" b="0" i="0" dirty="0" err="1">
+                <a:solidFill>
+                  <a:srgbClr val="D0D8E8"/>
+                </a:solidFill>
+              </a:rPr>
+              <a:t>voor</a:t>
+            </a:r>
+            <a:r>
+              <a:rPr sz="1400" b="0" i="0" dirty="0">
+                <a:solidFill>
+                  <a:srgbClr val="D0D8E8"/>
+                </a:solidFill>
+              </a:rPr>
+              <a:t> </a:t>
+            </a:r>
+            <a:r>
+              <a:rPr sz="1400" b="0" i="0" dirty="0" err="1">
+                <a:solidFill>
+                  <a:srgbClr val="D0D8E8"/>
+                </a:solidFill>
+              </a:rPr>
+              <a:t>langetermijntrend</a:t>
+            </a:r>
+            <a:r>
+              <a:rPr sz="1400" b="0" i="0" dirty="0">
+                <a:solidFill>
+                  <a:srgbClr val="D0D8E8"/>
+                </a:solidFill>
+              </a:rPr>
+              <a:t>- &amp; </a:t>
+            </a:r>
+            <a:r>
+              <a:rPr sz="1400" b="0" i="0" dirty="0" err="1">
+                <a:solidFill>
+                  <a:srgbClr val="D0D8E8"/>
+                </a:solidFill>
+              </a:rPr>
+              <a:t>regressiedetectie</a:t>
+            </a:r>
+            <a:endParaRPr sz="1400" b="0" i="0" dirty="0">
+              <a:solidFill>
+                <a:srgbClr val="D0D8E8"/>
+              </a:solidFill>
+            </a:endParaRPr>
           </a:p>
           <a:p>
             <a:pPr algn="l">
@@ -10015,12 +11476,92 @@
               </a:spcBef>
             </a:pPr>
             <a:r>
-              <a:rPr sz="1400" b="0" i="0">
-                <a:solidFill>
-                  <a:srgbClr val="D0D8E8"/>
-                </a:solidFill>
-              </a:rPr>
-              <a:t>›  PDF-export met één klik voor zowel het dashboard als de interlock-boom</a:t>
+              <a:rPr sz="1400" b="0" i="0" dirty="0">
+                <a:solidFill>
+                  <a:srgbClr val="D0D8E8"/>
+                </a:solidFill>
+              </a:rPr>
+              <a:t>›  PDF-export met </a:t>
+            </a:r>
+            <a:r>
+              <a:rPr sz="1400" b="0" i="0" dirty="0" err="1">
+                <a:solidFill>
+                  <a:srgbClr val="D0D8E8"/>
+                </a:solidFill>
+              </a:rPr>
+              <a:t>één</a:t>
+            </a:r>
+            <a:r>
+              <a:rPr sz="1400" b="0" i="0" dirty="0">
+                <a:solidFill>
+                  <a:srgbClr val="D0D8E8"/>
+                </a:solidFill>
+              </a:rPr>
+              <a:t> </a:t>
+            </a:r>
+            <a:r>
+              <a:rPr sz="1400" b="0" i="0" dirty="0" err="1">
+                <a:solidFill>
+                  <a:srgbClr val="D0D8E8"/>
+                </a:solidFill>
+              </a:rPr>
+              <a:t>klik</a:t>
+            </a:r>
+            <a:r>
+              <a:rPr sz="1400" b="0" i="0" dirty="0">
+                <a:solidFill>
+                  <a:srgbClr val="D0D8E8"/>
+                </a:solidFill>
+              </a:rPr>
+              <a:t> </a:t>
+            </a:r>
+            <a:r>
+              <a:rPr sz="1400" b="0" i="0" dirty="0" err="1">
+                <a:solidFill>
+                  <a:srgbClr val="D0D8E8"/>
+                </a:solidFill>
+              </a:rPr>
+              <a:t>voor</a:t>
+            </a:r>
+            <a:r>
+              <a:rPr sz="1400" b="0" i="0" dirty="0">
+                <a:solidFill>
+                  <a:srgbClr val="D0D8E8"/>
+                </a:solidFill>
+              </a:rPr>
+              <a:t> </a:t>
+            </a:r>
+            <a:r>
+              <a:rPr sz="1400" b="0" i="0" dirty="0" err="1">
+                <a:solidFill>
+                  <a:srgbClr val="D0D8E8"/>
+                </a:solidFill>
+              </a:rPr>
+              <a:t>zowel</a:t>
+            </a:r>
+            <a:r>
+              <a:rPr sz="1400" b="0" i="0" dirty="0">
+                <a:solidFill>
+                  <a:srgbClr val="D0D8E8"/>
+                </a:solidFill>
+              </a:rPr>
+              <a:t> het dashboard </a:t>
+            </a:r>
+            <a:r>
+              <a:rPr sz="1400" b="0" i="0" dirty="0" err="1">
+                <a:solidFill>
+                  <a:srgbClr val="D0D8E8"/>
+                </a:solidFill>
+              </a:rPr>
+              <a:t>als</a:t>
+            </a:r>
+            <a:r>
+              <a:rPr sz="1400" b="0" i="0" dirty="0">
+                <a:solidFill>
+                  <a:srgbClr val="D0D8E8"/>
+                </a:solidFill>
+              </a:rPr>
+              <a:t> de interlock-boom</a:t>
             </a:r>
           </a:p>
           <a:p>
@@ -10030,13 +11571,90 @@
               </a:spcBef>
             </a:pPr>
             <a:r>
-              <a:rPr sz="1400" b="0" i="0">
-                <a:solidFill>
-                  <a:srgbClr val="D0D8E8"/>
-                </a:solidFill>
-              </a:rPr>
-              <a:t>›  Query's onder de seconde via geoptimaliseerde SQL Server-TVF's en indexen</a:t>
-            </a:r>
+              <a:rPr sz="1400" b="0" i="0" dirty="0">
+                <a:solidFill>
+                  <a:srgbClr val="D0D8E8"/>
+                </a:solidFill>
+              </a:rPr>
+              <a:t>›  Query's </a:t>
+            </a:r>
+            <a:r>
+              <a:rPr sz="1400" b="0" i="0" dirty="0" err="1">
+                <a:solidFill>
+                  <a:srgbClr val="D0D8E8"/>
+                </a:solidFill>
+              </a:rPr>
+              <a:t>onder</a:t>
+            </a:r>
+            <a:r>
+              <a:rPr sz="1400" b="0" i="0" dirty="0">
+                <a:solidFill>
+                  <a:srgbClr val="D0D8E8"/>
+                </a:solidFill>
+              </a:rPr>
+              <a:t> de </a:t>
+            </a:r>
+            <a:r>
+              <a:rPr sz="1400" b="0" i="0" dirty="0" err="1">
+                <a:solidFill>
+                  <a:srgbClr val="D0D8E8"/>
+                </a:solidFill>
+              </a:rPr>
+              <a:t>seconde</a:t>
+            </a:r>
+            <a:r>
+              <a:rPr sz="1400" b="0" i="0" dirty="0">
+                <a:solidFill>
+                  <a:srgbClr val="D0D8E8"/>
+                </a:solidFill>
+              </a:rPr>
+              <a:t> via </a:t>
+            </a:r>
+            <a:r>
+              <a:rPr sz="1400" b="0" i="0" dirty="0" err="1">
+                <a:solidFill>
+                  <a:srgbClr val="D0D8E8"/>
+                </a:solidFill>
+              </a:rPr>
+              <a:t>geoptimaliseerde</a:t>
+            </a:r>
+            <a:r>
+              <a:rPr sz="1400" b="0" i="0" dirty="0">
+                <a:solidFill>
+                  <a:srgbClr val="D0D8E8"/>
+                </a:solidFill>
+              </a:rPr>
+              <a:t> SQL Server-TVF's </a:t>
+            </a:r>
+            <a:r>
+              <a:rPr sz="1400" b="0" i="0" dirty="0" err="1">
+                <a:solidFill>
+                  <a:srgbClr val="D0D8E8"/>
+                </a:solidFill>
+              </a:rPr>
+              <a:t>en</a:t>
+            </a:r>
+            <a:r>
+              <a:rPr sz="1400" b="0" i="0" dirty="0">
+                <a:solidFill>
+                  <a:srgbClr val="D0D8E8"/>
+                </a:solidFill>
+              </a:rPr>
+              <a:t> </a:t>
+            </a:r>
+            <a:r>
+              <a:rPr sz="1400" b="0" i="0" dirty="0" err="1">
+                <a:solidFill>
+                  <a:srgbClr val="D0D8E8"/>
+                </a:solidFill>
+              </a:rPr>
+              <a:t>indexen</a:t>
+            </a:r>
+            <a:endParaRPr sz="1400" b="0" i="0" dirty="0">
+              <a:solidFill>
+                <a:srgbClr val="D0D8E8"/>
+              </a:solidFill>
+            </a:endParaRPr>
           </a:p>
         </p:txBody>
       </p:sp>
@@ -10049,7 +11667,7 @@
 </file>
 
 <file path=ppt/slides/slide4.xml><?xml version="1.0" encoding="utf-8"?>
-<p:sld xmlns:a="http://schemas.openxmlformats.org/drawingml/2006/main" xmlns:p="http://schemas.openxmlformats.org/presentationml/2006/main" xmlns:r="http://schemas.openxmlformats.org/officeDocument/2006/relationships">
+<p:sld xmlns:a="http://schemas.openxmlformats.org/drawingml/2006/main" xmlns:r="http://schemas.openxmlformats.org/officeDocument/2006/relationships" xmlns:p="http://schemas.openxmlformats.org/presentationml/2006/main">
   <p:cSld>
     <p:spTree>
       <p:nvGrpSpPr>
@@ -10057,7 +11675,14 @@
         <p:cNvGrpSpPr/>
         <p:nvPr/>
       </p:nvGrpSpPr>
-      <p:grpSpPr/>
+      <p:grpSpPr>
+        <a:xfrm>
+          <a:off x="0" y="0"/>
+          <a:ext cx="0" cy="0"/>
+          <a:chOff x="0" y="0"/>
+          <a:chExt cx="0" cy="0"/>
+        </a:xfrm>
+      </p:grpSpPr>
       <p:sp>
         <p:nvSpPr>
           <p:cNvPr id="2" name="Rectangle 1"/>
@@ -10098,6 +11723,7 @@
           <a:lstStyle/>
           <a:p>
             <a:pPr algn="ctr"/>
+            <a:endParaRPr/>
           </a:p>
         </p:txBody>
       </p:sp>
@@ -10141,6 +11767,7 @@
           <a:lstStyle/>
           <a:p>
             <a:pPr algn="ctr"/>
+            <a:endParaRPr/>
           </a:p>
         </p:txBody>
       </p:sp>
@@ -10276,6 +11903,7 @@
           <a:lstStyle/>
           <a:p>
             <a:pPr algn="ctr"/>
+            <a:endParaRPr/>
           </a:p>
         </p:txBody>
       </p:sp>
@@ -10319,6 +11947,7 @@
           <a:lstStyle/>
           <a:p>
             <a:pPr algn="ctr"/>
+            <a:endParaRPr/>
           </a:p>
         </p:txBody>
       </p:sp>
@@ -10362,6 +11991,7 @@
           <a:lstStyle/>
           <a:p>
             <a:pPr algn="ctr"/>
+            <a:endParaRPr/>
           </a:p>
         </p:txBody>
       </p:sp>
@@ -10507,6 +12137,7 @@
           <a:lstStyle/>
           <a:p>
             <a:pPr algn="ctr"/>
+            <a:endParaRPr/>
           </a:p>
         </p:txBody>
       </p:sp>
@@ -10550,6 +12181,7 @@
           <a:lstStyle/>
           <a:p>
             <a:pPr algn="ctr"/>
+            <a:endParaRPr/>
           </a:p>
         </p:txBody>
       </p:sp>
@@ -10593,6 +12225,7 @@
           <a:lstStyle/>
           <a:p>
             <a:pPr algn="ctr"/>
+            <a:endParaRPr/>
           </a:p>
         </p:txBody>
       </p:sp>
@@ -10688,12 +12321,148 @@
           <a:p>
             <a:pPr algn="l"/>
             <a:r>
-              <a:rPr sz="1100" b="0" i="0">
-                <a:solidFill>
-                  <a:srgbClr val="D0D8E8"/>
-                </a:solidFill>
-              </a:rPr>
-              <a:t>Onderhoudstechnici hadden geen eigen applicatie — enkel de ruwe, real-time CIMPLICITY-alarmen zonder historiek.</a:t>
+              <a:rPr sz="1100" b="0" i="0" dirty="0" err="1">
+                <a:solidFill>
+                  <a:srgbClr val="D0D8E8"/>
+                </a:solidFill>
+              </a:rPr>
+              <a:t>Onderhoudstechnici</a:t>
+            </a:r>
+            <a:r>
+              <a:rPr sz="1100" b="0" i="0" dirty="0">
+                <a:solidFill>
+                  <a:srgbClr val="D0D8E8"/>
+                </a:solidFill>
+              </a:rPr>
+              <a:t> </a:t>
+            </a:r>
+            <a:r>
+              <a:rPr sz="1100" b="0" i="0" dirty="0" err="1">
+                <a:solidFill>
+                  <a:srgbClr val="D0D8E8"/>
+                </a:solidFill>
+              </a:rPr>
+              <a:t>hadden</a:t>
+            </a:r>
+            <a:r>
+              <a:rPr sz="1100" b="0" i="0" dirty="0">
+                <a:solidFill>
+                  <a:srgbClr val="D0D8E8"/>
+                </a:solidFill>
+              </a:rPr>
+              <a:t> </a:t>
+            </a:r>
+            <a:r>
+              <a:rPr sz="1100" b="0" i="0" dirty="0" err="1">
+                <a:solidFill>
+                  <a:srgbClr val="D0D8E8"/>
+                </a:solidFill>
+              </a:rPr>
+              <a:t>geen</a:t>
+            </a:r>
+            <a:r>
+              <a:rPr sz="1100" b="0" i="0" dirty="0">
+                <a:solidFill>
+                  <a:srgbClr val="D0D8E8"/>
+                </a:solidFill>
+              </a:rPr>
+              <a:t> eigen </a:t>
+            </a:r>
+            <a:r>
+              <a:rPr sz="1100" b="0" i="0" dirty="0" err="1">
+                <a:solidFill>
+                  <a:srgbClr val="D0D8E8"/>
+                </a:solidFill>
+              </a:rPr>
+              <a:t>applicatie</a:t>
+            </a:r>
+            <a:r>
+              <a:rPr sz="1100" b="0" i="0" dirty="0">
+                <a:solidFill>
+                  <a:srgbClr val="D0D8E8"/>
+                </a:solidFill>
+              </a:rPr>
+              <a:t> — </a:t>
+            </a:r>
+            <a:r>
+              <a:rPr sz="1100" b="0" i="0" dirty="0" err="1">
+                <a:solidFill>
+                  <a:srgbClr val="D0D8E8"/>
+                </a:solidFill>
+              </a:rPr>
+              <a:t>enkel</a:t>
+            </a:r>
+            <a:r>
+              <a:rPr sz="1100" b="0" i="0" dirty="0">
+                <a:solidFill>
+                  <a:srgbClr val="D0D8E8"/>
+                </a:solidFill>
+              </a:rPr>
+              <a:t> de </a:t>
+            </a:r>
+            <a:r>
+              <a:rPr sz="1100" b="0" i="0" dirty="0" err="1">
+                <a:solidFill>
+                  <a:srgbClr val="D0D8E8"/>
+                </a:solidFill>
+              </a:rPr>
+              <a:t>ruwe</a:t>
+            </a:r>
+            <a:r>
+              <a:rPr sz="1100" b="0" i="0" dirty="0">
+                <a:solidFill>
+                  <a:srgbClr val="D0D8E8"/>
+                </a:solidFill>
+              </a:rPr>
+              <a:t>, real-time CIMPLICITY-</a:t>
+            </a:r>
+            <a:r>
+              <a:rPr sz="1100" b="0" i="0" dirty="0" err="1">
+                <a:solidFill>
+                  <a:srgbClr val="D0D8E8"/>
+                </a:solidFill>
+              </a:rPr>
+              <a:t>alarmen</a:t>
+            </a:r>
+            <a:r>
+              <a:rPr sz="1100" b="0" i="0" dirty="0">
+                <a:solidFill>
+                  <a:srgbClr val="D0D8E8"/>
+                </a:solidFill>
+              </a:rPr>
+              <a:t> </a:t>
+            </a:r>
+            <a:r>
+              <a:rPr sz="1100" b="0" i="0" dirty="0" err="1">
+                <a:solidFill>
+                  <a:srgbClr val="D0D8E8"/>
+                </a:solidFill>
+              </a:rPr>
+              <a:t>zonder</a:t>
+            </a:r>
+            <a:r>
+              <a:rPr sz="1100" b="0" i="0" dirty="0">
+                <a:solidFill>
+                  <a:srgbClr val="D0D8E8"/>
+                </a:solidFill>
+              </a:rPr>
+              <a:t> </a:t>
+            </a:r>
+            <a:r>
+              <a:rPr sz="1100" b="0" i="0" dirty="0" err="1">
+                <a:solidFill>
+                  <a:srgbClr val="D0D8E8"/>
+                </a:solidFill>
+              </a:rPr>
+              <a:t>historiek</a:t>
+            </a:r>
+            <a:r>
+              <a:rPr sz="1100" b="0" i="0" dirty="0">
+                <a:solidFill>
+                  <a:srgbClr val="D0D8E8"/>
+                </a:solidFill>
+              </a:rPr>
+              <a:t>.</a:t>
             </a:r>
           </a:p>
         </p:txBody>
@@ -10738,6 +12507,7 @@
           <a:lstStyle/>
           <a:p>
             <a:pPr algn="ctr"/>
+            <a:endParaRPr/>
           </a:p>
         </p:txBody>
       </p:sp>
@@ -10781,6 +12551,7 @@
           <a:lstStyle/>
           <a:p>
             <a:pPr algn="ctr"/>
+            <a:endParaRPr/>
           </a:p>
         </p:txBody>
       </p:sp>
@@ -10824,6 +12595,7 @@
           <a:lstStyle/>
           <a:p>
             <a:pPr algn="ctr"/>
+            <a:endParaRPr/>
           </a:p>
         </p:txBody>
       </p:sp>
@@ -10969,6 +12741,7 @@
           <a:lstStyle/>
           <a:p>
             <a:pPr algn="ctr"/>
+            <a:endParaRPr/>
           </a:p>
         </p:txBody>
       </p:sp>
@@ -11012,6 +12785,7 @@
           <a:lstStyle/>
           <a:p>
             <a:pPr algn="ctr"/>
+            <a:endParaRPr/>
           </a:p>
         </p:txBody>
       </p:sp>
@@ -11055,6 +12829,7 @@
           <a:lstStyle/>
           <a:p>
             <a:pPr algn="ctr"/>
+            <a:endParaRPr/>
           </a:p>
         </p:txBody>
       </p:sp>
@@ -11200,6 +12975,7 @@
           <a:lstStyle/>
           <a:p>
             <a:pPr algn="ctr"/>
+            <a:endParaRPr/>
           </a:p>
         </p:txBody>
       </p:sp>
@@ -11243,6 +13019,7 @@
           <a:lstStyle/>
           <a:p>
             <a:pPr algn="ctr"/>
+            <a:endParaRPr/>
           </a:p>
         </p:txBody>
       </p:sp>
@@ -11286,6 +13063,7 @@
           <a:lstStyle/>
           <a:p>
             <a:pPr algn="ctr"/>
+            <a:endParaRPr/>
           </a:p>
         </p:txBody>
       </p:sp>
@@ -11431,6 +13209,7 @@
           <a:lstStyle/>
           <a:p>
             <a:pPr algn="ctr"/>
+            <a:endParaRPr/>
           </a:p>
         </p:txBody>
       </p:sp>
@@ -11474,6 +13253,7 @@
           <a:lstStyle/>
           <a:p>
             <a:pPr algn="ctr"/>
+            <a:endParaRPr/>
           </a:p>
         </p:txBody>
       </p:sp>
@@ -11517,6 +13297,7 @@
           <a:lstStyle/>
           <a:p>
             <a:pPr algn="ctr"/>
+            <a:endParaRPr/>
           </a:p>
         </p:txBody>
       </p:sp>
@@ -11631,7 +13412,7 @@
 </file>
 
 <file path=ppt/slides/slide5.xml><?xml version="1.0" encoding="utf-8"?>
-<p:sld xmlns:a="http://schemas.openxmlformats.org/drawingml/2006/main" xmlns:p="http://schemas.openxmlformats.org/presentationml/2006/main" xmlns:r="http://schemas.openxmlformats.org/officeDocument/2006/relationships">
+<p:sld xmlns:a="http://schemas.openxmlformats.org/drawingml/2006/main" xmlns:r="http://schemas.openxmlformats.org/officeDocument/2006/relationships" xmlns:p="http://schemas.openxmlformats.org/presentationml/2006/main">
   <p:cSld>
     <p:spTree>
       <p:nvGrpSpPr>
@@ -11639,7 +13420,14 @@
         <p:cNvGrpSpPr/>
         <p:nvPr/>
       </p:nvGrpSpPr>
-      <p:grpSpPr/>
+      <p:grpSpPr>
+        <a:xfrm>
+          <a:off x="0" y="0"/>
+          <a:ext cx="0" cy="0"/>
+          <a:chOff x="0" y="0"/>
+          <a:chExt cx="0" cy="0"/>
+        </a:xfrm>
+      </p:grpSpPr>
       <p:sp>
         <p:nvSpPr>
           <p:cNvPr id="2" name="Rectangle 1"/>
@@ -11680,6 +13468,7 @@
           <a:lstStyle/>
           <a:p>
             <a:pPr algn="ctr"/>
+            <a:endParaRPr/>
           </a:p>
         </p:txBody>
       </p:sp>
@@ -11723,6 +13512,7 @@
           <a:lstStyle/>
           <a:p>
             <a:pPr algn="ctr"/>
+            <a:endParaRPr/>
           </a:p>
         </p:txBody>
       </p:sp>
@@ -11858,6 +13648,7 @@
           <a:lstStyle/>
           <a:p>
             <a:pPr algn="ctr"/>
+            <a:endParaRPr/>
           </a:p>
         </p:txBody>
       </p:sp>
@@ -11901,6 +13692,7 @@
           <a:lstStyle/>
           <a:p>
             <a:pPr algn="ctr"/>
+            <a:endParaRPr/>
           </a:p>
         </p:txBody>
       </p:sp>
@@ -11944,6 +13736,7 @@
           <a:lstStyle/>
           <a:p>
             <a:pPr algn="ctr"/>
+            <a:endParaRPr/>
           </a:p>
         </p:txBody>
       </p:sp>
@@ -12002,7 +13795,9 @@
             <a:spAutoFit/>
           </a:bodyPr>
           <a:lstStyle/>
-          <a:p/>
+          <a:p>
+            <a:endParaRPr/>
+          </a:p>
           <a:p>
             <a:pPr algn="l">
               <a:spcBef>
@@ -12105,6 +13900,7 @@
           <a:lstStyle/>
           <a:p>
             <a:pPr algn="ctr"/>
+            <a:endParaRPr/>
           </a:p>
         </p:txBody>
       </p:sp>
@@ -12163,7 +13959,9 @@
             <a:spAutoFit/>
           </a:bodyPr>
           <a:lstStyle/>
-          <a:p/>
+          <a:p>
+            <a:endParaRPr/>
+          </a:p>
           <a:p>
             <a:pPr algn="l">
               <a:spcBef>
@@ -12300,6 +14098,7 @@
           <a:lstStyle/>
           <a:p>
             <a:pPr algn="ctr"/>
+            <a:endParaRPr/>
           </a:p>
         </p:txBody>
       </p:sp>
@@ -12377,6 +14176,7 @@
           <a:lstStyle/>
           <a:p>
             <a:pPr algn="ctr"/>
+            <a:endParaRPr/>
           </a:p>
         </p:txBody>
       </p:sp>
@@ -12420,6 +14220,7 @@
           <a:lstStyle/>
           <a:p>
             <a:pPr algn="ctr"/>
+            <a:endParaRPr/>
           </a:p>
         </p:txBody>
       </p:sp>
@@ -12497,6 +14298,7 @@
           <a:lstStyle/>
           <a:p>
             <a:pPr algn="ctr"/>
+            <a:endParaRPr/>
           </a:p>
         </p:txBody>
       </p:sp>
@@ -12540,6 +14342,7 @@
           <a:lstStyle/>
           <a:p>
             <a:pPr algn="ctr"/>
+            <a:endParaRPr/>
           </a:p>
         </p:txBody>
       </p:sp>
@@ -12617,6 +14420,7 @@
           <a:lstStyle/>
           <a:p>
             <a:pPr algn="ctr"/>
+            <a:endParaRPr/>
           </a:p>
         </p:txBody>
       </p:sp>
@@ -12660,6 +14464,7 @@
           <a:lstStyle/>
           <a:p>
             <a:pPr algn="ctr"/>
+            <a:endParaRPr/>
           </a:p>
         </p:txBody>
       </p:sp>
@@ -12737,6 +14542,7 @@
           <a:lstStyle/>
           <a:p>
             <a:pPr algn="ctr"/>
+            <a:endParaRPr/>
           </a:p>
         </p:txBody>
       </p:sp>
@@ -12780,6 +14586,7 @@
           <a:lstStyle/>
           <a:p>
             <a:pPr algn="ctr"/>
+            <a:endParaRPr/>
           </a:p>
         </p:txBody>
       </p:sp>
@@ -12826,7 +14633,7 @@
 </file>
 
 <file path=ppt/slides/slide6.xml><?xml version="1.0" encoding="utf-8"?>
-<p:sld xmlns:a="http://schemas.openxmlformats.org/drawingml/2006/main" xmlns:p="http://schemas.openxmlformats.org/presentationml/2006/main" xmlns:r="http://schemas.openxmlformats.org/officeDocument/2006/relationships">
+<p:sld xmlns:a="http://schemas.openxmlformats.org/drawingml/2006/main" xmlns:r="http://schemas.openxmlformats.org/officeDocument/2006/relationships" xmlns:p="http://schemas.openxmlformats.org/presentationml/2006/main">
   <p:cSld>
     <p:spTree>
       <p:nvGrpSpPr>
@@ -12834,7 +14641,14 @@
         <p:cNvGrpSpPr/>
         <p:nvPr/>
       </p:nvGrpSpPr>
-      <p:grpSpPr/>
+      <p:grpSpPr>
+        <a:xfrm>
+          <a:off x="0" y="0"/>
+          <a:ext cx="0" cy="0"/>
+          <a:chOff x="0" y="0"/>
+          <a:chExt cx="0" cy="0"/>
+        </a:xfrm>
+      </p:grpSpPr>
       <p:sp>
         <p:nvSpPr>
           <p:cNvPr id="2" name="Rectangle 1"/>
@@ -12875,6 +14689,7 @@
           <a:lstStyle/>
           <a:p>
             <a:pPr algn="ctr"/>
+            <a:endParaRPr/>
           </a:p>
         </p:txBody>
       </p:sp>
@@ -12918,6 +14733,7 @@
           <a:lstStyle/>
           <a:p>
             <a:pPr algn="ctr"/>
+            <a:endParaRPr/>
           </a:p>
         </p:txBody>
       </p:sp>
@@ -13169,6 +14985,7 @@
           <a:lstStyle/>
           <a:p>
             <a:pPr algn="ctr"/>
+            <a:endParaRPr/>
           </a:p>
         </p:txBody>
       </p:sp>
@@ -13215,7 +15032,7 @@
 </file>
 
 <file path=ppt/slides/slide7.xml><?xml version="1.0" encoding="utf-8"?>
-<p:sld xmlns:a="http://schemas.openxmlformats.org/drawingml/2006/main" xmlns:p="http://schemas.openxmlformats.org/presentationml/2006/main" xmlns:r="http://schemas.openxmlformats.org/officeDocument/2006/relationships">
+<p:sld xmlns:a="http://schemas.openxmlformats.org/drawingml/2006/main" xmlns:r="http://schemas.openxmlformats.org/officeDocument/2006/relationships" xmlns:p="http://schemas.openxmlformats.org/presentationml/2006/main">
   <p:cSld>
     <p:spTree>
       <p:nvGrpSpPr>
@@ -13223,7 +15040,14 @@
         <p:cNvGrpSpPr/>
         <p:nvPr/>
       </p:nvGrpSpPr>
-      <p:grpSpPr/>
+      <p:grpSpPr>
+        <a:xfrm>
+          <a:off x="0" y="0"/>
+          <a:ext cx="0" cy="0"/>
+          <a:chOff x="0" y="0"/>
+          <a:chExt cx="0" cy="0"/>
+        </a:xfrm>
+      </p:grpSpPr>
       <p:sp>
         <p:nvSpPr>
           <p:cNvPr id="2" name="Rectangle 1"/>
@@ -13264,6 +15088,7 @@
           <a:lstStyle/>
           <a:p>
             <a:pPr algn="ctr"/>
+            <a:endParaRPr/>
           </a:p>
         </p:txBody>
       </p:sp>
@@ -13307,6 +15132,7 @@
           <a:lstStyle/>
           <a:p>
             <a:pPr algn="ctr"/>
+            <a:endParaRPr/>
           </a:p>
         </p:txBody>
       </p:sp>
@@ -13466,6 +15292,7 @@
           <a:lstStyle/>
           <a:p>
             <a:pPr algn="ctr"/>
+            <a:endParaRPr/>
           </a:p>
         </p:txBody>
       </p:sp>
@@ -13567,6 +15394,7 @@
           <a:lstStyle/>
           <a:p>
             <a:pPr algn="ctr"/>
+            <a:endParaRPr/>
           </a:p>
         </p:txBody>
       </p:sp>
@@ -13668,6 +15496,7 @@
           <a:lstStyle/>
           <a:p>
             <a:pPr algn="ctr"/>
+            <a:endParaRPr/>
           </a:p>
         </p:txBody>
       </p:sp>
@@ -13769,6 +15598,7 @@
           <a:lstStyle/>
           <a:p>
             <a:pPr algn="ctr"/>
+            <a:endParaRPr/>
           </a:p>
         </p:txBody>
       </p:sp>
@@ -13870,6 +15700,7 @@
           <a:lstStyle/>
           <a:p>
             <a:pPr algn="ctr"/>
+            <a:endParaRPr/>
           </a:p>
         </p:txBody>
       </p:sp>
@@ -13947,6 +15778,7 @@
           <a:lstStyle/>
           <a:p>
             <a:pPr algn="ctr"/>
+            <a:endParaRPr/>
           </a:p>
         </p:txBody>
       </p:sp>
@@ -14024,6 +15856,7 @@
           <a:lstStyle/>
           <a:p>
             <a:pPr algn="ctr"/>
+            <a:endParaRPr/>
           </a:p>
         </p:txBody>
       </p:sp>
@@ -14203,6 +16036,7 @@
           <a:lstStyle/>
           <a:p>
             <a:pPr algn="ctr"/>
+            <a:endParaRPr/>
           </a:p>
         </p:txBody>
       </p:sp>
@@ -14382,6 +16216,7 @@
           <a:lstStyle/>
           <a:p>
             <a:pPr algn="ctr"/>
+            <a:endParaRPr/>
           </a:p>
         </p:txBody>
       </p:sp>
@@ -14561,6 +16396,7 @@
           <a:lstStyle/>
           <a:p>
             <a:pPr algn="ctr"/>
+            <a:endParaRPr/>
           </a:p>
         </p:txBody>
       </p:sp>
@@ -14740,6 +16576,7 @@
           <a:lstStyle/>
           <a:p>
             <a:pPr algn="ctr"/>
+            <a:endParaRPr/>
           </a:p>
         </p:txBody>
       </p:sp>
@@ -14888,7 +16725,7 @@
 </file>
 
 <file path=ppt/slides/slide8.xml><?xml version="1.0" encoding="utf-8"?>
-<p:sld xmlns:a="http://schemas.openxmlformats.org/drawingml/2006/main" xmlns:p="http://schemas.openxmlformats.org/presentationml/2006/main" xmlns:r="http://schemas.openxmlformats.org/officeDocument/2006/relationships">
+<p:sld xmlns:a="http://schemas.openxmlformats.org/drawingml/2006/main" xmlns:r="http://schemas.openxmlformats.org/officeDocument/2006/relationships" xmlns:p="http://schemas.openxmlformats.org/presentationml/2006/main">
   <p:cSld>
     <p:spTree>
       <p:nvGrpSpPr>
@@ -14896,7 +16733,14 @@
         <p:cNvGrpSpPr/>
         <p:nvPr/>
       </p:nvGrpSpPr>
-      <p:grpSpPr/>
+      <p:grpSpPr>
+        <a:xfrm>
+          <a:off x="0" y="0"/>
+          <a:ext cx="0" cy="0"/>
+          <a:chOff x="0" y="0"/>
+          <a:chExt cx="0" cy="0"/>
+        </a:xfrm>
+      </p:grpSpPr>
       <p:sp>
         <p:nvSpPr>
           <p:cNvPr id="2" name="Rectangle 1"/>
@@ -14937,6 +16781,7 @@
           <a:lstStyle/>
           <a:p>
             <a:pPr algn="ctr"/>
+            <a:endParaRPr/>
           </a:p>
         </p:txBody>
       </p:sp>
@@ -14980,6 +16825,7 @@
           <a:lstStyle/>
           <a:p>
             <a:pPr algn="ctr"/>
+            <a:endParaRPr/>
           </a:p>
         </p:txBody>
       </p:sp>
@@ -15173,6 +17019,7 @@
           <a:lstStyle/>
           <a:p>
             <a:pPr algn="ctr"/>
+            <a:endParaRPr/>
           </a:p>
         </p:txBody>
       </p:sp>
@@ -15231,7 +17078,9 @@
             <a:spAutoFit/>
           </a:bodyPr>
           <a:lstStyle/>
-          <a:p/>
+          <a:p>
+            <a:endParaRPr/>
+          </a:p>
           <a:p>
             <a:pPr algn="l">
               <a:spcBef>
@@ -15318,7 +17167,7 @@
 </file>
 
 <file path=ppt/slides/slide9.xml><?xml version="1.0" encoding="utf-8"?>
-<p:sld xmlns:a="http://schemas.openxmlformats.org/drawingml/2006/main" xmlns:p="http://schemas.openxmlformats.org/presentationml/2006/main" xmlns:r="http://schemas.openxmlformats.org/officeDocument/2006/relationships">
+<p:sld xmlns:a="http://schemas.openxmlformats.org/drawingml/2006/main" xmlns:r="http://schemas.openxmlformats.org/officeDocument/2006/relationships" xmlns:p="http://schemas.openxmlformats.org/presentationml/2006/main">
   <p:cSld>
     <p:spTree>
       <p:nvGrpSpPr>
@@ -15326,7 +17175,14 @@
         <p:cNvGrpSpPr/>
         <p:nvPr/>
       </p:nvGrpSpPr>
-      <p:grpSpPr/>
+      <p:grpSpPr>
+        <a:xfrm>
+          <a:off x="0" y="0"/>
+          <a:ext cx="0" cy="0"/>
+          <a:chOff x="0" y="0"/>
+          <a:chExt cx="0" cy="0"/>
+        </a:xfrm>
+      </p:grpSpPr>
       <p:sp>
         <p:nvSpPr>
           <p:cNvPr id="2" name="Rectangle 1"/>
@@ -15367,6 +17223,7 @@
           <a:lstStyle/>
           <a:p>
             <a:pPr algn="ctr"/>
+            <a:endParaRPr/>
           </a:p>
         </p:txBody>
       </p:sp>
@@ -15410,6 +17267,7 @@
           <a:lstStyle/>
           <a:p>
             <a:pPr algn="ctr"/>
+            <a:endParaRPr/>
           </a:p>
         </p:txBody>
       </p:sp>
@@ -15545,6 +17403,7 @@
           <a:lstStyle/>
           <a:p>
             <a:pPr algn="ctr"/>
+            <a:endParaRPr/>
           </a:p>
         </p:txBody>
       </p:sp>
@@ -15656,6 +17515,7 @@
           <a:lstStyle/>
           <a:p>
             <a:pPr algn="ctr"/>
+            <a:endParaRPr/>
           </a:p>
         </p:txBody>
       </p:sp>
@@ -15767,6 +17627,7 @@
           <a:lstStyle/>
           <a:p>
             <a:pPr algn="ctr"/>
+            <a:endParaRPr/>
           </a:p>
         </p:txBody>
       </p:sp>
@@ -15878,6 +17739,7 @@
           <a:lstStyle/>
           <a:p>
             <a:pPr algn="ctr"/>
+            <a:endParaRPr/>
           </a:p>
         </p:txBody>
       </p:sp>
@@ -15989,6 +17851,7 @@
           <a:lstStyle/>
           <a:p>
             <a:pPr algn="ctr"/>
+            <a:endParaRPr/>
           </a:p>
         </p:txBody>
       </p:sp>
@@ -16100,6 +17963,7 @@
           <a:lstStyle/>
           <a:p>
             <a:pPr algn="ctr"/>
+            <a:endParaRPr/>
           </a:p>
         </p:txBody>
       </p:sp>
@@ -16211,6 +18075,7 @@
           <a:lstStyle/>
           <a:p>
             <a:pPr algn="ctr"/>
+            <a:endParaRPr/>
           </a:p>
         </p:txBody>
       </p:sp>
@@ -16322,6 +18187,7 @@
           <a:lstStyle/>
           <a:p>
             <a:pPr algn="ctr"/>
+            <a:endParaRPr/>
           </a:p>
         </p:txBody>
       </p:sp>
@@ -16433,6 +18299,7 @@
           <a:lstStyle/>
           <a:p>
             <a:pPr algn="ctr"/>
+            <a:endParaRPr/>
           </a:p>
         </p:txBody>
       </p:sp>
@@ -16544,6 +18411,7 @@
           <a:lstStyle/>
           <a:p>
             <a:pPr algn="ctr"/>
+            <a:endParaRPr/>
           </a:p>
         </p:txBody>
       </p:sp>
@@ -16655,6 +18523,7 @@
           <a:lstStyle/>
           <a:p>
             <a:pPr algn="ctr"/>
+            <a:endParaRPr/>
           </a:p>
         </p:txBody>
       </p:sp>

</xml_diff>